<commit_message>
Save Year 6 lesson refinements and generation scripts before Blob Storage migration
</commit_message>
<xml_diff>
--- a/public/lessons/year-6-maths/autumn/week-1/calculate-intervals-across-zero/teaching-powerpoint-v1.pptx
+++ b/public/lessons/year-6-maths/autumn/week-1/calculate-intervals-across-zero/teaching-powerpoint-v1.pptx
@@ -2,24 +2,24 @@
 <file path=ppt/presentation.xml><?xml version="1.0" encoding="utf-8"?>
 <p:presentation xmlns:p="http://schemas.openxmlformats.org/presentationml/2006/main">
   <p:sldMasterIdLst>
-    <p:sldMasterId xmlns:r="http://schemas.openxmlformats.org/officeDocument/2006/relationships" id="2147483648" r:id="Rd14b6cd93a984edd"/>
+    <p:sldMasterId xmlns:r="http://schemas.openxmlformats.org/officeDocument/2006/relationships" id="2147483648" r:id="Rd2fc974fb0d84e3c"/>
   </p:sldMasterIdLst>
   <p:notesMasterIdLst>
-    <p:notesMasterId xmlns:r="http://schemas.openxmlformats.org/officeDocument/2006/relationships" r:id="R3dd117334ffb4eb5"/>
+    <p:notesMasterId xmlns:r="http://schemas.openxmlformats.org/officeDocument/2006/relationships" r:id="Rf7a49f72628a46d0"/>
   </p:notesMasterIdLst>
   <p:sldIdLst>
-    <p:sldId xmlns:r="http://schemas.openxmlformats.org/officeDocument/2006/relationships" id="256" r:id="Rf760737287c94e4d"/>
-    <p:sldId xmlns:r="http://schemas.openxmlformats.org/officeDocument/2006/relationships" id="257" r:id="Re04ef42f64304132"/>
-    <p:sldId xmlns:r="http://schemas.openxmlformats.org/officeDocument/2006/relationships" id="258" r:id="Re0b9e3e4bff24a99"/>
-    <p:sldId xmlns:r="http://schemas.openxmlformats.org/officeDocument/2006/relationships" id="259" r:id="Rb49cd4da8c2342b6"/>
-    <p:sldId xmlns:r="http://schemas.openxmlformats.org/officeDocument/2006/relationships" id="260" r:id="R5d868847b24341b9"/>
-    <p:sldId xmlns:r="http://schemas.openxmlformats.org/officeDocument/2006/relationships" id="261" r:id="R36d4575329064fb3"/>
-    <p:sldId xmlns:r="http://schemas.openxmlformats.org/officeDocument/2006/relationships" id="262" r:id="Rdd3ec1e0cea544d4"/>
-    <p:sldId xmlns:r="http://schemas.openxmlformats.org/officeDocument/2006/relationships" id="263" r:id="R22c8335170e646e9"/>
-    <p:sldId xmlns:r="http://schemas.openxmlformats.org/officeDocument/2006/relationships" id="264" r:id="Rab94c7fa382d4fc9"/>
-    <p:sldId xmlns:r="http://schemas.openxmlformats.org/officeDocument/2006/relationships" id="265" r:id="R8657bcd5f8df439f"/>
-    <p:sldId xmlns:r="http://schemas.openxmlformats.org/officeDocument/2006/relationships" id="266" r:id="Re428124a1c944a31"/>
-    <p:sldId xmlns:r="http://schemas.openxmlformats.org/officeDocument/2006/relationships" id="267" r:id="R980844e6ac9244d3"/>
+    <p:sldId xmlns:r="http://schemas.openxmlformats.org/officeDocument/2006/relationships" id="256" r:id="R1c9f572091ff49e1"/>
+    <p:sldId xmlns:r="http://schemas.openxmlformats.org/officeDocument/2006/relationships" id="257" r:id="Re47abed61e234387"/>
+    <p:sldId xmlns:r="http://schemas.openxmlformats.org/officeDocument/2006/relationships" id="258" r:id="Rca3ca4c0db0c4cd7"/>
+    <p:sldId xmlns:r="http://schemas.openxmlformats.org/officeDocument/2006/relationships" id="259" r:id="Rfe262a3565ea4a8f"/>
+    <p:sldId xmlns:r="http://schemas.openxmlformats.org/officeDocument/2006/relationships" id="260" r:id="R4043a9e982954939"/>
+    <p:sldId xmlns:r="http://schemas.openxmlformats.org/officeDocument/2006/relationships" id="261" r:id="Rc3ba9808d4ee41d8"/>
+    <p:sldId xmlns:r="http://schemas.openxmlformats.org/officeDocument/2006/relationships" id="262" r:id="Rd36c66c3a6ee4b58"/>
+    <p:sldId xmlns:r="http://schemas.openxmlformats.org/officeDocument/2006/relationships" id="263" r:id="Rbd329027c4ea4470"/>
+    <p:sldId xmlns:r="http://schemas.openxmlformats.org/officeDocument/2006/relationships" id="264" r:id="R832c0868402749fa"/>
+    <p:sldId xmlns:r="http://schemas.openxmlformats.org/officeDocument/2006/relationships" id="265" r:id="Rcaffae521b18478a"/>
+    <p:sldId xmlns:r="http://schemas.openxmlformats.org/officeDocument/2006/relationships" id="266" r:id="R95c0708cab2246cf"/>
+    <p:sldId xmlns:r="http://schemas.openxmlformats.org/officeDocument/2006/relationships" id="267" r:id="Ref975adb01b74582"/>
   </p:sldIdLst>
   <p:sldSz cx="12192000" cy="6858000"/>
   <p:notesSz cx="6858000" cy="9144000"/>
@@ -873,7 +873,7 @@
           <a:lstStyle xmlns:a="http://schemas.openxmlformats.org/drawingml/2006/main"/>
           <a:p xmlns:a="http://schemas.openxmlformats.org/drawingml/2006/main">
             <a:r>
-              <a:t>I do. Reveal the question, setup and each calculation stage one click at a time. Pupils watch before copying. Model answer: 11.</a:t>
+              <a:t>I do. Reveal the question, then reveal each mathematical change one click at a time. Point to the numbers and operation that changed before moving to the next line. Final answer: 11.</a:t>
             </a:r>
           </a:p>
         </p:txBody>
@@ -1291,7 +1291,7 @@
   </p:cSld>
   <p:clrMap bg1="lt1" tx1="dk1" bg2="lt2" tx2="dk2" accent1="accent1" accent2="accent2" accent3="accent3" accent4="accent4" accent5="accent5" accent6="accent6" hlink="hlink" folHlink="folHlink"/>
   <p:sldLayoutIdLst>
-    <p:sldLayoutId xmlns:r="http://schemas.openxmlformats.org/officeDocument/2006/relationships" id="2147483649" r:id="Rdd9bdd1e9b16433d"/>
+    <p:sldLayoutId xmlns:r="http://schemas.openxmlformats.org/officeDocument/2006/relationships" id="2147483649" r:id="Ra6bd97c86adb4d30"/>
   </p:sldLayoutIdLst>
   <p:txStyles>
     <p:titleStyle>
@@ -1842,7 +1842,7 @@
           <p:cNvPr id="12" name="">
             <a:extLst xmlns:a="http://schemas.openxmlformats.org/drawingml/2006/main">
               <a:ext uri="{FF2B5EF4-FFF2-40B4-BE49-F238E27FC236}">
-                <a16:creationId xmlns:a16="http://schemas.microsoft.com/office/drawing/2014/main" id="{3FD4AA5F-A5DC-4822-973A-CF736FB4E5E6}"/>
+                <a16:creationId xmlns:a16="http://schemas.microsoft.com/office/drawing/2014/main" id="{2762B492-37F2-48BC-A69C-93B34C8CDBFB}"/>
               </a:ext>
             </a:extLst>
           </p:cNvPr>
@@ -1874,7 +1874,7 @@
           <p:cNvPr id="2" name="">
             <a:extLst xmlns:a="http://schemas.openxmlformats.org/drawingml/2006/main">
               <a:ext uri="{FF2B5EF4-FFF2-40B4-BE49-F238E27FC236}">
-                <a16:creationId xmlns:a16="http://schemas.microsoft.com/office/drawing/2014/main" id="{5D44E1DE-CEEF-46A2-B371-DC84F3D2C2FB}"/>
+                <a16:creationId xmlns:a16="http://schemas.microsoft.com/office/drawing/2014/main" id="{6A70C386-962A-44FE-914C-EAE949DFDAEE}"/>
               </a:ext>
             </a:extLst>
           </p:cNvPr>
@@ -1931,7 +1931,7 @@
           <p:cNvPr id="3" name="">
             <a:extLst xmlns:a="http://schemas.openxmlformats.org/drawingml/2006/main">
               <a:ext uri="{FF2B5EF4-FFF2-40B4-BE49-F238E27FC236}">
-                <a16:creationId xmlns:a16="http://schemas.microsoft.com/office/drawing/2014/main" id="{2F9E4172-5ED1-4B2F-BB77-4EC007F75F53}"/>
+                <a16:creationId xmlns:a16="http://schemas.microsoft.com/office/drawing/2014/main" id="{1B759202-6E6F-41D1-B4C3-5241D966DF26}"/>
               </a:ext>
             </a:extLst>
           </p:cNvPr>
@@ -1965,7 +1965,7 @@
           <p:cNvPr id="4" name="">
             <a:extLst xmlns:a="http://schemas.openxmlformats.org/drawingml/2006/main">
               <a:ext uri="{FF2B5EF4-FFF2-40B4-BE49-F238E27FC236}">
-                <a16:creationId xmlns:a16="http://schemas.microsoft.com/office/drawing/2014/main" id="{FFEBF8D4-1D1F-4025-A59E-A57D0F05764B}"/>
+                <a16:creationId xmlns:a16="http://schemas.microsoft.com/office/drawing/2014/main" id="{E9C11DE7-5E55-4B6E-AED6-2C72F41E0DFA}"/>
               </a:ext>
             </a:extLst>
           </p:cNvPr>
@@ -2022,7 +2022,7 @@
           <p:cNvPr id="5" name="">
             <a:extLst xmlns:a="http://schemas.openxmlformats.org/drawingml/2006/main">
               <a:ext uri="{FF2B5EF4-FFF2-40B4-BE49-F238E27FC236}">
-                <a16:creationId xmlns:a16="http://schemas.microsoft.com/office/drawing/2014/main" id="{51DDF35B-BE38-4D01-A631-68BCFCD68B90}"/>
+                <a16:creationId xmlns:a16="http://schemas.microsoft.com/office/drawing/2014/main" id="{F0704653-F600-421A-8A79-2CEEDE84547D}"/>
               </a:ext>
             </a:extLst>
           </p:cNvPr>
@@ -2079,7 +2079,7 @@
           <p:cNvPr id="6" name="">
             <a:extLst xmlns:a="http://schemas.openxmlformats.org/drawingml/2006/main">
               <a:ext uri="{FF2B5EF4-FFF2-40B4-BE49-F238E27FC236}">
-                <a16:creationId xmlns:a16="http://schemas.microsoft.com/office/drawing/2014/main" id="{7C9F616F-73CD-40F5-A842-EDC2E0CE68FC}"/>
+                <a16:creationId xmlns:a16="http://schemas.microsoft.com/office/drawing/2014/main" id="{B5CB3FE0-4ECD-4262-A605-522FF7313942}"/>
               </a:ext>
             </a:extLst>
           </p:cNvPr>
@@ -2113,7 +2113,7 @@
           <p:cNvPr id="7" name="">
             <a:extLst xmlns:a="http://schemas.openxmlformats.org/drawingml/2006/main">
               <a:ext uri="{FF2B5EF4-FFF2-40B4-BE49-F238E27FC236}">
-                <a16:creationId xmlns:a16="http://schemas.microsoft.com/office/drawing/2014/main" id="{201AFF25-0A58-4C41-9909-EC260F25E9D5}"/>
+                <a16:creationId xmlns:a16="http://schemas.microsoft.com/office/drawing/2014/main" id="{B26E2680-F98D-48EC-A145-0F55F61D299E}"/>
               </a:ext>
             </a:extLst>
           </p:cNvPr>
@@ -2170,7 +2170,7 @@
           <p:cNvPr id="8" name="">
             <a:extLst xmlns:a="http://schemas.openxmlformats.org/drawingml/2006/main">
               <a:ext uri="{FF2B5EF4-FFF2-40B4-BE49-F238E27FC236}">
-                <a16:creationId xmlns:a16="http://schemas.microsoft.com/office/drawing/2014/main" id="{4BE50185-2DA7-46A9-880B-178B47618572}"/>
+                <a16:creationId xmlns:a16="http://schemas.microsoft.com/office/drawing/2014/main" id="{B494F767-1018-4ADE-8D74-DB2029B96AD7}"/>
               </a:ext>
             </a:extLst>
           </p:cNvPr>
@@ -2227,7 +2227,7 @@
           <p:cNvPr id="9" name="">
             <a:extLst xmlns:a="http://schemas.openxmlformats.org/drawingml/2006/main">
               <a:ext uri="{FF2B5EF4-FFF2-40B4-BE49-F238E27FC236}">
-                <a16:creationId xmlns:a16="http://schemas.microsoft.com/office/drawing/2014/main" id="{BCD60AFA-15A5-4D92-B882-C54D4A71C2F0}"/>
+                <a16:creationId xmlns:a16="http://schemas.microsoft.com/office/drawing/2014/main" id="{DB887A20-0B54-4AC5-9870-C8ED7B7A284B}"/>
               </a:ext>
             </a:extLst>
           </p:cNvPr>
@@ -2284,7 +2284,7 @@
           <p:cNvPr id="10" name="">
             <a:extLst xmlns:a="http://schemas.openxmlformats.org/drawingml/2006/main">
               <a:ext uri="{FF2B5EF4-FFF2-40B4-BE49-F238E27FC236}">
-                <a16:creationId xmlns:a16="http://schemas.microsoft.com/office/drawing/2014/main" id="{6E001B48-8809-4A07-B8E6-9994723D04CC}"/>
+                <a16:creationId xmlns:a16="http://schemas.microsoft.com/office/drawing/2014/main" id="{91238E5C-DF42-4991-9790-F03CCEA95465}"/>
               </a:ext>
             </a:extLst>
           </p:cNvPr>
@@ -2341,7 +2341,7 @@
           <p:cNvPr id="11" name="">
             <a:extLst xmlns:a="http://schemas.openxmlformats.org/drawingml/2006/main">
               <a:ext uri="{FF2B5EF4-FFF2-40B4-BE49-F238E27FC236}">
-                <a16:creationId xmlns:a16="http://schemas.microsoft.com/office/drawing/2014/main" id="{104BC236-9A47-40DB-B886-485A4690E454}"/>
+                <a16:creationId xmlns:a16="http://schemas.microsoft.com/office/drawing/2014/main" id="{36D239CB-C248-4A78-8C7A-01DE1198665B}"/>
               </a:ext>
             </a:extLst>
           </p:cNvPr>
@@ -2396,7 +2396,7 @@
     </p:spTree>
     <p:extLst>
       <p:ext uri="{BB962C8B-B14F-4D97-AF65-F5344CB8AC3E}">
-        <p14:creationId xmlns:p14="http://schemas.microsoft.com/office/powerpoint/2010/main" val="1427319683"/>
+        <p14:creationId xmlns:p14="http://schemas.microsoft.com/office/powerpoint/2010/main" val="1140703070"/>
       </p:ext>
     </p:extLst>
   </p:cSld>
@@ -2427,7 +2427,7 @@
           <p:cNvPr id="14" name="">
             <a:extLst xmlns:a="http://schemas.openxmlformats.org/drawingml/2006/main">
               <a:ext uri="{FF2B5EF4-FFF2-40B4-BE49-F238E27FC236}">
-                <a16:creationId xmlns:a16="http://schemas.microsoft.com/office/drawing/2014/main" id="{F6D9CA1E-48BF-45A3-8C75-77980B8FB63B}"/>
+                <a16:creationId xmlns:a16="http://schemas.microsoft.com/office/drawing/2014/main" id="{F824E9C1-724D-4DF1-86E0-B2B8FDA3F353}"/>
               </a:ext>
             </a:extLst>
           </p:cNvPr>
@@ -2459,7 +2459,7 @@
           <p:cNvPr id="2" name="">
             <a:extLst xmlns:a="http://schemas.openxmlformats.org/drawingml/2006/main">
               <a:ext uri="{FF2B5EF4-FFF2-40B4-BE49-F238E27FC236}">
-                <a16:creationId xmlns:a16="http://schemas.microsoft.com/office/drawing/2014/main" id="{5C3D9F3D-9C75-472B-986B-CBEC0BB91CEC}"/>
+                <a16:creationId xmlns:a16="http://schemas.microsoft.com/office/drawing/2014/main" id="{A62BF881-3421-4CD2-ADDA-EB0B4092BED2}"/>
               </a:ext>
             </a:extLst>
           </p:cNvPr>
@@ -2516,7 +2516,7 @@
           <p:cNvPr id="3" name="">
             <a:extLst xmlns:a="http://schemas.openxmlformats.org/drawingml/2006/main">
               <a:ext uri="{FF2B5EF4-FFF2-40B4-BE49-F238E27FC236}">
-                <a16:creationId xmlns:a16="http://schemas.microsoft.com/office/drawing/2014/main" id="{0C21435B-AEDA-4509-95D5-57023900C25F}"/>
+                <a16:creationId xmlns:a16="http://schemas.microsoft.com/office/drawing/2014/main" id="{89971DC2-922E-4EDD-821C-5A39DC77C0C9}"/>
               </a:ext>
             </a:extLst>
           </p:cNvPr>
@@ -2548,7 +2548,7 @@
           <p:cNvPr id="4" name="">
             <a:extLst xmlns:a="http://schemas.openxmlformats.org/drawingml/2006/main">
               <a:ext uri="{FF2B5EF4-FFF2-40B4-BE49-F238E27FC236}">
-                <a16:creationId xmlns:a16="http://schemas.microsoft.com/office/drawing/2014/main" id="{742465CB-FFFE-45A9-9D57-DB337BF54E09}"/>
+                <a16:creationId xmlns:a16="http://schemas.microsoft.com/office/drawing/2014/main" id="{ECE2E23A-B07A-4EAA-B7E7-80B3621853DA}"/>
               </a:ext>
             </a:extLst>
           </p:cNvPr>
@@ -2605,7 +2605,7 @@
           <p:cNvPr id="5" name="">
             <a:extLst xmlns:a="http://schemas.openxmlformats.org/drawingml/2006/main">
               <a:ext uri="{FF2B5EF4-FFF2-40B4-BE49-F238E27FC236}">
-                <a16:creationId xmlns:a16="http://schemas.microsoft.com/office/drawing/2014/main" id="{5D2E7F88-E28F-4579-9D54-A41D10A4CA85}"/>
+                <a16:creationId xmlns:a16="http://schemas.microsoft.com/office/drawing/2014/main" id="{4E6CD009-E8F8-44EB-8FBF-3E85B1AB3E3C}"/>
               </a:ext>
             </a:extLst>
           </p:cNvPr>
@@ -2662,7 +2662,7 @@
           <p:cNvPr id="6" name="">
             <a:extLst xmlns:a="http://schemas.openxmlformats.org/drawingml/2006/main">
               <a:ext uri="{FF2B5EF4-FFF2-40B4-BE49-F238E27FC236}">
-                <a16:creationId xmlns:a16="http://schemas.microsoft.com/office/drawing/2014/main" id="{E3F94209-B425-47CA-BD4B-F2130D48D8F4}"/>
+                <a16:creationId xmlns:a16="http://schemas.microsoft.com/office/drawing/2014/main" id="{324A9DED-B266-4CC3-8F29-DA3B541970DD}"/>
               </a:ext>
             </a:extLst>
           </p:cNvPr>
@@ -2719,7 +2719,7 @@
           <p:cNvPr id="7" name="">
             <a:extLst xmlns:a="http://schemas.openxmlformats.org/drawingml/2006/main">
               <a:ext uri="{FF2B5EF4-FFF2-40B4-BE49-F238E27FC236}">
-                <a16:creationId xmlns:a16="http://schemas.microsoft.com/office/drawing/2014/main" id="{8053F39E-14BA-4B08-9D20-90C5484298D6}"/>
+                <a16:creationId xmlns:a16="http://schemas.microsoft.com/office/drawing/2014/main" id="{6DA27E3E-8675-4C1E-ADB5-188842FD0E8A}"/>
               </a:ext>
             </a:extLst>
           </p:cNvPr>
@@ -2751,7 +2751,7 @@
           <p:cNvPr id="8" name="">
             <a:extLst xmlns:a="http://schemas.openxmlformats.org/drawingml/2006/main">
               <a:ext uri="{FF2B5EF4-FFF2-40B4-BE49-F238E27FC236}">
-                <a16:creationId xmlns:a16="http://schemas.microsoft.com/office/drawing/2014/main" id="{5634581B-E423-4AC0-92C2-A6DC4242DE83}"/>
+                <a16:creationId xmlns:a16="http://schemas.microsoft.com/office/drawing/2014/main" id="{1776D9D7-69D7-4838-81C3-88AD12828800}"/>
               </a:ext>
             </a:extLst>
           </p:cNvPr>
@@ -2808,7 +2808,7 @@
           <p:cNvPr id="9" name="">
             <a:extLst xmlns:a="http://schemas.openxmlformats.org/drawingml/2006/main">
               <a:ext uri="{FF2B5EF4-FFF2-40B4-BE49-F238E27FC236}">
-                <a16:creationId xmlns:a16="http://schemas.microsoft.com/office/drawing/2014/main" id="{25B268AC-1C66-4467-9C16-40CDD0F3F9DF}"/>
+                <a16:creationId xmlns:a16="http://schemas.microsoft.com/office/drawing/2014/main" id="{27E8287E-F529-4BA6-ADC2-AEA77E232CEB}"/>
               </a:ext>
             </a:extLst>
           </p:cNvPr>
@@ -2865,7 +2865,7 @@
           <p:cNvPr id="10" name="">
             <a:extLst xmlns:a="http://schemas.openxmlformats.org/drawingml/2006/main">
               <a:ext uri="{FF2B5EF4-FFF2-40B4-BE49-F238E27FC236}">
-                <a16:creationId xmlns:a16="http://schemas.microsoft.com/office/drawing/2014/main" id="{92688C05-73FC-4756-B27A-3FB15786CFA0}"/>
+                <a16:creationId xmlns:a16="http://schemas.microsoft.com/office/drawing/2014/main" id="{5364CAAE-4B58-4CEE-8704-DA32F849089E}"/>
               </a:ext>
             </a:extLst>
           </p:cNvPr>
@@ -2922,7 +2922,7 @@
           <p:cNvPr id="11" name="">
             <a:extLst xmlns:a="http://schemas.openxmlformats.org/drawingml/2006/main">
               <a:ext uri="{FF2B5EF4-FFF2-40B4-BE49-F238E27FC236}">
-                <a16:creationId xmlns:a16="http://schemas.microsoft.com/office/drawing/2014/main" id="{7BF0E388-D78B-4860-8043-2A81167A3A84}"/>
+                <a16:creationId xmlns:a16="http://schemas.microsoft.com/office/drawing/2014/main" id="{1A9127C4-80BA-4F47-8CF6-85EC3F19F448}"/>
               </a:ext>
             </a:extLst>
           </p:cNvPr>
@@ -2979,7 +2979,7 @@
           <p:cNvPr id="12" name="">
             <a:extLst xmlns:a="http://schemas.openxmlformats.org/drawingml/2006/main">
               <a:ext uri="{FF2B5EF4-FFF2-40B4-BE49-F238E27FC236}">
-                <a16:creationId xmlns:a16="http://schemas.microsoft.com/office/drawing/2014/main" id="{28D94B88-5AE3-42D1-9024-C1CE8181DD1E}"/>
+                <a16:creationId xmlns:a16="http://schemas.microsoft.com/office/drawing/2014/main" id="{88B52970-A323-4350-AC59-0101E24F759C}"/>
               </a:ext>
             </a:extLst>
           </p:cNvPr>
@@ -3036,7 +3036,7 @@
           <p:cNvPr id="13" name="">
             <a:extLst xmlns:a="http://schemas.openxmlformats.org/drawingml/2006/main">
               <a:ext uri="{FF2B5EF4-FFF2-40B4-BE49-F238E27FC236}">
-                <a16:creationId xmlns:a16="http://schemas.microsoft.com/office/drawing/2014/main" id="{D28FBA0E-0F98-458E-AFD3-76E1295A458C}"/>
+                <a16:creationId xmlns:a16="http://schemas.microsoft.com/office/drawing/2014/main" id="{32DB9AB9-C414-4E4B-ACE5-BA8F85A28A54}"/>
               </a:ext>
             </a:extLst>
           </p:cNvPr>
@@ -3091,7 +3091,7 @@
     </p:spTree>
     <p:extLst>
       <p:ext uri="{BB962C8B-B14F-4D97-AF65-F5344CB8AC3E}">
-        <p14:creationId xmlns:p14="http://schemas.microsoft.com/office/powerpoint/2010/main" val="1876701820"/>
+        <p14:creationId xmlns:p14="http://schemas.microsoft.com/office/powerpoint/2010/main" val="1851389829"/>
       </p:ext>
     </p:extLst>
   </p:cSld>
@@ -3292,7 +3292,7 @@
           <p:cNvPr id="19" name="">
             <a:extLst xmlns:a="http://schemas.openxmlformats.org/drawingml/2006/main">
               <a:ext uri="{FF2B5EF4-FFF2-40B4-BE49-F238E27FC236}">
-                <a16:creationId xmlns:a16="http://schemas.microsoft.com/office/drawing/2014/main" id="{70411DAA-5E3A-4EEE-B843-CF1A22B3C0CE}"/>
+                <a16:creationId xmlns:a16="http://schemas.microsoft.com/office/drawing/2014/main" id="{B42BA1D5-B7F4-4CA6-86F5-16AAB61E9B04}"/>
               </a:ext>
             </a:extLst>
           </p:cNvPr>
@@ -3324,7 +3324,7 @@
           <p:cNvPr id="2" name="">
             <a:extLst xmlns:a="http://schemas.openxmlformats.org/drawingml/2006/main">
               <a:ext uri="{FF2B5EF4-FFF2-40B4-BE49-F238E27FC236}">
-                <a16:creationId xmlns:a16="http://schemas.microsoft.com/office/drawing/2014/main" id="{83291FD3-3905-4E99-BC92-CC2E3ED984C6}"/>
+                <a16:creationId xmlns:a16="http://schemas.microsoft.com/office/drawing/2014/main" id="{D55ADF07-D7AF-4844-A75A-76C051EB181A}"/>
               </a:ext>
             </a:extLst>
           </p:cNvPr>
@@ -3381,7 +3381,7 @@
           <p:cNvPr id="3" name="">
             <a:extLst xmlns:a="http://schemas.openxmlformats.org/drawingml/2006/main">
               <a:ext uri="{FF2B5EF4-FFF2-40B4-BE49-F238E27FC236}">
-                <a16:creationId xmlns:a16="http://schemas.microsoft.com/office/drawing/2014/main" id="{B1215335-5B7D-4D25-85BB-ECCC2BC9171E}"/>
+                <a16:creationId xmlns:a16="http://schemas.microsoft.com/office/drawing/2014/main" id="{459C1194-D487-476B-B791-5CC5423E1F09}"/>
               </a:ext>
             </a:extLst>
           </p:cNvPr>
@@ -3413,7 +3413,7 @@
           <p:cNvPr id="4" name="">
             <a:extLst xmlns:a="http://schemas.openxmlformats.org/drawingml/2006/main">
               <a:ext uri="{FF2B5EF4-FFF2-40B4-BE49-F238E27FC236}">
-                <a16:creationId xmlns:a16="http://schemas.microsoft.com/office/drawing/2014/main" id="{EAC63071-FD05-41FE-8F55-EB08E3D41CD1}"/>
+                <a16:creationId xmlns:a16="http://schemas.microsoft.com/office/drawing/2014/main" id="{72B1F068-B7A5-43F8-9F6E-FC1E7AED88EB}"/>
               </a:ext>
             </a:extLst>
           </p:cNvPr>
@@ -3470,7 +3470,7 @@
           <p:cNvPr id="5" name="">
             <a:extLst xmlns:a="http://schemas.openxmlformats.org/drawingml/2006/main">
               <a:ext uri="{FF2B5EF4-FFF2-40B4-BE49-F238E27FC236}">
-                <a16:creationId xmlns:a16="http://schemas.microsoft.com/office/drawing/2014/main" id="{906E9593-57EA-4AD0-8592-9F6FB6AF0B45}"/>
+                <a16:creationId xmlns:a16="http://schemas.microsoft.com/office/drawing/2014/main" id="{25BF8D88-F08C-44B9-ABAD-7D4D9855D13E}"/>
               </a:ext>
             </a:extLst>
           </p:cNvPr>
@@ -3527,7 +3527,7 @@
           <p:cNvPr id="6" name="">
             <a:extLst xmlns:a="http://schemas.openxmlformats.org/drawingml/2006/main">
               <a:ext uri="{FF2B5EF4-FFF2-40B4-BE49-F238E27FC236}">
-                <a16:creationId xmlns:a16="http://schemas.microsoft.com/office/drawing/2014/main" id="{8EF08E66-C6A2-4232-971B-FF6B35C0C2FB}"/>
+                <a16:creationId xmlns:a16="http://schemas.microsoft.com/office/drawing/2014/main" id="{AAE4C3AD-7ACB-4B07-A705-8FED171617B6}"/>
               </a:ext>
             </a:extLst>
           </p:cNvPr>
@@ -3584,7 +3584,7 @@
           <p:cNvPr id="7" name="">
             <a:extLst xmlns:a="http://schemas.openxmlformats.org/drawingml/2006/main">
               <a:ext uri="{FF2B5EF4-FFF2-40B4-BE49-F238E27FC236}">
-                <a16:creationId xmlns:a16="http://schemas.microsoft.com/office/drawing/2014/main" id="{D532ABF9-6E06-4E57-8EC2-D1E771EF6D8F}"/>
+                <a16:creationId xmlns:a16="http://schemas.microsoft.com/office/drawing/2014/main" id="{69EDA33C-884F-4940-B10B-AB16C2F91499}"/>
               </a:ext>
             </a:extLst>
           </p:cNvPr>
@@ -3616,7 +3616,7 @@
           <p:cNvPr id="8" name="">
             <a:extLst xmlns:a="http://schemas.openxmlformats.org/drawingml/2006/main">
               <a:ext uri="{FF2B5EF4-FFF2-40B4-BE49-F238E27FC236}">
-                <a16:creationId xmlns:a16="http://schemas.microsoft.com/office/drawing/2014/main" id="{EE414E6C-CA0B-4B7C-A145-99A3CDBE16A3}"/>
+                <a16:creationId xmlns:a16="http://schemas.microsoft.com/office/drawing/2014/main" id="{959C9988-3664-48E9-80E7-3F135849D514}"/>
               </a:ext>
             </a:extLst>
           </p:cNvPr>
@@ -3673,7 +3673,7 @@
           <p:cNvPr id="9" name="">
             <a:extLst xmlns:a="http://schemas.openxmlformats.org/drawingml/2006/main">
               <a:ext uri="{FF2B5EF4-FFF2-40B4-BE49-F238E27FC236}">
-                <a16:creationId xmlns:a16="http://schemas.microsoft.com/office/drawing/2014/main" id="{767D38DA-BE16-49EC-A21E-4709A1002167}"/>
+                <a16:creationId xmlns:a16="http://schemas.microsoft.com/office/drawing/2014/main" id="{04B9A652-2E01-4C41-9588-03BB246A5A0A}"/>
               </a:ext>
             </a:extLst>
           </p:cNvPr>
@@ -3730,7 +3730,7 @@
           <p:cNvPr id="10" name="">
             <a:extLst xmlns:a="http://schemas.openxmlformats.org/drawingml/2006/main">
               <a:ext uri="{FF2B5EF4-FFF2-40B4-BE49-F238E27FC236}">
-                <a16:creationId xmlns:a16="http://schemas.microsoft.com/office/drawing/2014/main" id="{9ED6BCC0-21B2-4D25-92BE-ACA6DD44D432}"/>
+                <a16:creationId xmlns:a16="http://schemas.microsoft.com/office/drawing/2014/main" id="{85AD2E96-A333-4AEE-BA84-6CC7F939393D}"/>
               </a:ext>
             </a:extLst>
           </p:cNvPr>
@@ -3787,7 +3787,7 @@
           <p:cNvPr id="11" name="">
             <a:extLst xmlns:a="http://schemas.openxmlformats.org/drawingml/2006/main">
               <a:ext uri="{FF2B5EF4-FFF2-40B4-BE49-F238E27FC236}">
-                <a16:creationId xmlns:a16="http://schemas.microsoft.com/office/drawing/2014/main" id="{75902F00-1F4C-44F6-9F69-C8D1CE51BD69}"/>
+                <a16:creationId xmlns:a16="http://schemas.microsoft.com/office/drawing/2014/main" id="{F0AEF099-176C-45C7-8812-3B0C5910814C}"/>
               </a:ext>
             </a:extLst>
           </p:cNvPr>
@@ -3821,7 +3821,7 @@
           <p:cNvPr id="12" name="">
             <a:extLst xmlns:a="http://schemas.openxmlformats.org/drawingml/2006/main">
               <a:ext uri="{FF2B5EF4-FFF2-40B4-BE49-F238E27FC236}">
-                <a16:creationId xmlns:a16="http://schemas.microsoft.com/office/drawing/2014/main" id="{75846AA5-1561-4D23-897E-AA90CD4D407B}"/>
+                <a16:creationId xmlns:a16="http://schemas.microsoft.com/office/drawing/2014/main" id="{A36E4845-2004-4236-86ED-7653E7947712}"/>
               </a:ext>
             </a:extLst>
           </p:cNvPr>
@@ -3878,7 +3878,7 @@
           <p:cNvPr id="13" name="">
             <a:extLst xmlns:a="http://schemas.openxmlformats.org/drawingml/2006/main">
               <a:ext uri="{FF2B5EF4-FFF2-40B4-BE49-F238E27FC236}">
-                <a16:creationId xmlns:a16="http://schemas.microsoft.com/office/drawing/2014/main" id="{A0341FB9-7B13-4ED8-B34B-5F39EB6E779E}"/>
+                <a16:creationId xmlns:a16="http://schemas.microsoft.com/office/drawing/2014/main" id="{C82E6687-04B6-45FF-96EF-886C694CE6CE}"/>
               </a:ext>
             </a:extLst>
           </p:cNvPr>
@@ -3935,7 +3935,7 @@
           <p:cNvPr id="14" name="">
             <a:extLst xmlns:a="http://schemas.openxmlformats.org/drawingml/2006/main">
               <a:ext uri="{FF2B5EF4-FFF2-40B4-BE49-F238E27FC236}">
-                <a16:creationId xmlns:a16="http://schemas.microsoft.com/office/drawing/2014/main" id="{9BBC7431-B5E1-4097-89B5-B7D000D7CD48}"/>
+                <a16:creationId xmlns:a16="http://schemas.microsoft.com/office/drawing/2014/main" id="{DE30F9EF-0909-483A-9FAC-E08496325891}"/>
               </a:ext>
             </a:extLst>
           </p:cNvPr>
@@ -3992,7 +3992,7 @@
           <p:cNvPr id="15" name="">
             <a:extLst xmlns:a="http://schemas.openxmlformats.org/drawingml/2006/main">
               <a:ext uri="{FF2B5EF4-FFF2-40B4-BE49-F238E27FC236}">
-                <a16:creationId xmlns:a16="http://schemas.microsoft.com/office/drawing/2014/main" id="{9F33F8B9-EB48-418A-BB99-F3CECE850480}"/>
+                <a16:creationId xmlns:a16="http://schemas.microsoft.com/office/drawing/2014/main" id="{92E57B36-0EE2-4924-8BAE-830F7237F8A8}"/>
               </a:ext>
             </a:extLst>
           </p:cNvPr>
@@ -4026,7 +4026,7 @@
           <p:cNvPr id="16" name="">
             <a:extLst xmlns:a="http://schemas.openxmlformats.org/drawingml/2006/main">
               <a:ext uri="{FF2B5EF4-FFF2-40B4-BE49-F238E27FC236}">
-                <a16:creationId xmlns:a16="http://schemas.microsoft.com/office/drawing/2014/main" id="{7937FAB9-8438-4675-ABD8-51192AE7620B}"/>
+                <a16:creationId xmlns:a16="http://schemas.microsoft.com/office/drawing/2014/main" id="{5DD7865B-D090-42E9-B299-83F46A0B2B8A}"/>
               </a:ext>
             </a:extLst>
           </p:cNvPr>
@@ -4083,7 +4083,7 @@
           <p:cNvPr id="17" name="">
             <a:extLst xmlns:a="http://schemas.openxmlformats.org/drawingml/2006/main">
               <a:ext uri="{FF2B5EF4-FFF2-40B4-BE49-F238E27FC236}">
-                <a16:creationId xmlns:a16="http://schemas.microsoft.com/office/drawing/2014/main" id="{99E74124-7B40-4054-BD2D-0FCBF857E4CB}"/>
+                <a16:creationId xmlns:a16="http://schemas.microsoft.com/office/drawing/2014/main" id="{8268E654-B28D-4F6C-B4BC-BABE5CD92979}"/>
               </a:ext>
             </a:extLst>
           </p:cNvPr>
@@ -4140,7 +4140,7 @@
           <p:cNvPr id="18" name="">
             <a:extLst xmlns:a="http://schemas.openxmlformats.org/drawingml/2006/main">
               <a:ext uri="{FF2B5EF4-FFF2-40B4-BE49-F238E27FC236}">
-                <a16:creationId xmlns:a16="http://schemas.microsoft.com/office/drawing/2014/main" id="{2337DADD-431D-4483-8476-43B113CBF1C6}"/>
+                <a16:creationId xmlns:a16="http://schemas.microsoft.com/office/drawing/2014/main" id="{6B77D8B2-6539-4B71-B1A0-80A086D498EC}"/>
               </a:ext>
             </a:extLst>
           </p:cNvPr>
@@ -4195,7 +4195,7 @@
     </p:spTree>
     <p:extLst>
       <p:ext uri="{BB962C8B-B14F-4D97-AF65-F5344CB8AC3E}">
-        <p14:creationId xmlns:p14="http://schemas.microsoft.com/office/powerpoint/2010/main" val="211627002"/>
+        <p14:creationId xmlns:p14="http://schemas.microsoft.com/office/powerpoint/2010/main" val="1159498729"/>
       </p:ext>
     </p:extLst>
   </p:cSld>
@@ -4350,7 +4350,7 @@
           <p:cNvPr id="23" name="">
             <a:extLst xmlns:a="http://schemas.openxmlformats.org/drawingml/2006/main">
               <a:ext uri="{FF2B5EF4-FFF2-40B4-BE49-F238E27FC236}">
-                <a16:creationId xmlns:a16="http://schemas.microsoft.com/office/drawing/2014/main" id="{34A802CE-8E50-4CA3-8FB9-D0DFA40D4597}"/>
+                <a16:creationId xmlns:a16="http://schemas.microsoft.com/office/drawing/2014/main" id="{432E98E0-9AF9-40B0-BA02-B72DEBBDA1CA}"/>
               </a:ext>
             </a:extLst>
           </p:cNvPr>
@@ -4382,7 +4382,7 @@
           <p:cNvPr id="2" name="">
             <a:extLst xmlns:a="http://schemas.openxmlformats.org/drawingml/2006/main">
               <a:ext uri="{FF2B5EF4-FFF2-40B4-BE49-F238E27FC236}">
-                <a16:creationId xmlns:a16="http://schemas.microsoft.com/office/drawing/2014/main" id="{DCBBEAEB-267D-495D-9E72-8D5302C96E6D}"/>
+                <a16:creationId xmlns:a16="http://schemas.microsoft.com/office/drawing/2014/main" id="{25BC6F26-9623-4569-878B-056FEFF483CD}"/>
               </a:ext>
             </a:extLst>
           </p:cNvPr>
@@ -4439,7 +4439,7 @@
           <p:cNvPr id="3" name="">
             <a:extLst xmlns:a="http://schemas.openxmlformats.org/drawingml/2006/main">
               <a:ext uri="{FF2B5EF4-FFF2-40B4-BE49-F238E27FC236}">
-                <a16:creationId xmlns:a16="http://schemas.microsoft.com/office/drawing/2014/main" id="{21DF67B0-A8E3-4C7D-B5B2-67393698694D}"/>
+                <a16:creationId xmlns:a16="http://schemas.microsoft.com/office/drawing/2014/main" id="{F0D53C3E-14A1-4430-99F9-F41BB98C082C}"/>
               </a:ext>
             </a:extLst>
           </p:cNvPr>
@@ -4471,7 +4471,7 @@
           <p:cNvPr id="4" name="">
             <a:extLst xmlns:a="http://schemas.openxmlformats.org/drawingml/2006/main">
               <a:ext uri="{FF2B5EF4-FFF2-40B4-BE49-F238E27FC236}">
-                <a16:creationId xmlns:a16="http://schemas.microsoft.com/office/drawing/2014/main" id="{2991507E-38E4-464A-B057-0BFFBE39DE47}"/>
+                <a16:creationId xmlns:a16="http://schemas.microsoft.com/office/drawing/2014/main" id="{84253B22-5FD3-4421-8AA2-2D60B7C5ED7F}"/>
               </a:ext>
             </a:extLst>
           </p:cNvPr>
@@ -4528,7 +4528,7 @@
           <p:cNvPr id="5" name="">
             <a:extLst xmlns:a="http://schemas.openxmlformats.org/drawingml/2006/main">
               <a:ext uri="{FF2B5EF4-FFF2-40B4-BE49-F238E27FC236}">
-                <a16:creationId xmlns:a16="http://schemas.microsoft.com/office/drawing/2014/main" id="{0E4BAE88-3C47-485A-9C16-0E2CC9C7A065}"/>
+                <a16:creationId xmlns:a16="http://schemas.microsoft.com/office/drawing/2014/main" id="{E41EB26A-B5EA-4154-8A4E-174134B493FA}"/>
               </a:ext>
             </a:extLst>
           </p:cNvPr>
@@ -4585,7 +4585,7 @@
           <p:cNvPr id="6" name="">
             <a:extLst xmlns:a="http://schemas.openxmlformats.org/drawingml/2006/main">
               <a:ext uri="{FF2B5EF4-FFF2-40B4-BE49-F238E27FC236}">
-                <a16:creationId xmlns:a16="http://schemas.microsoft.com/office/drawing/2014/main" id="{EFA21A83-1DD2-48A4-9302-A05E1066891B}"/>
+                <a16:creationId xmlns:a16="http://schemas.microsoft.com/office/drawing/2014/main" id="{27EB2CD0-54E5-4FF8-A680-4B540EA60107}"/>
               </a:ext>
             </a:extLst>
           </p:cNvPr>
@@ -4642,7 +4642,7 @@
           <p:cNvPr id="7" name="">
             <a:extLst xmlns:a="http://schemas.openxmlformats.org/drawingml/2006/main">
               <a:ext uri="{FF2B5EF4-FFF2-40B4-BE49-F238E27FC236}">
-                <a16:creationId xmlns:a16="http://schemas.microsoft.com/office/drawing/2014/main" id="{C37ECF66-8F4F-4FB0-8A82-AF285694B4CD}"/>
+                <a16:creationId xmlns:a16="http://schemas.microsoft.com/office/drawing/2014/main" id="{11BDE07E-6A45-4989-9320-6FC13B0EE4D3}"/>
               </a:ext>
             </a:extLst>
           </p:cNvPr>
@@ -4674,7 +4674,7 @@
           <p:cNvPr id="8" name="">
             <a:extLst xmlns:a="http://schemas.openxmlformats.org/drawingml/2006/main">
               <a:ext uri="{FF2B5EF4-FFF2-40B4-BE49-F238E27FC236}">
-                <a16:creationId xmlns:a16="http://schemas.microsoft.com/office/drawing/2014/main" id="{940BF24C-AEB0-4505-9CD1-071ECAA4221E}"/>
+                <a16:creationId xmlns:a16="http://schemas.microsoft.com/office/drawing/2014/main" id="{42CFE2B2-1664-4909-97C4-E8982A6EFD2A}"/>
               </a:ext>
             </a:extLst>
           </p:cNvPr>
@@ -4731,7 +4731,7 @@
           <p:cNvPr id="9" name="">
             <a:extLst xmlns:a="http://schemas.openxmlformats.org/drawingml/2006/main">
               <a:ext uri="{FF2B5EF4-FFF2-40B4-BE49-F238E27FC236}">
-                <a16:creationId xmlns:a16="http://schemas.microsoft.com/office/drawing/2014/main" id="{660283F3-0798-455C-AFE7-827DCE0FB71E}"/>
+                <a16:creationId xmlns:a16="http://schemas.microsoft.com/office/drawing/2014/main" id="{C61CD9CE-282D-49F3-AD73-FE4FF589E526}"/>
               </a:ext>
             </a:extLst>
           </p:cNvPr>
@@ -4788,7 +4788,7 @@
           <p:cNvPr id="10" name="">
             <a:extLst xmlns:a="http://schemas.openxmlformats.org/drawingml/2006/main">
               <a:ext uri="{FF2B5EF4-FFF2-40B4-BE49-F238E27FC236}">
-                <a16:creationId xmlns:a16="http://schemas.microsoft.com/office/drawing/2014/main" id="{F2B55504-A8D5-4B94-ABBD-BBF837E740AE}"/>
+                <a16:creationId xmlns:a16="http://schemas.microsoft.com/office/drawing/2014/main" id="{C9A1EA70-A8CC-4D5C-B0A5-22765431F42D}"/>
               </a:ext>
             </a:extLst>
           </p:cNvPr>
@@ -4822,7 +4822,7 @@
           <p:cNvPr id="11" name="">
             <a:extLst xmlns:a="http://schemas.openxmlformats.org/drawingml/2006/main">
               <a:ext uri="{FF2B5EF4-FFF2-40B4-BE49-F238E27FC236}">
-                <a16:creationId xmlns:a16="http://schemas.microsoft.com/office/drawing/2014/main" id="{F40766D0-56A9-47E1-A9B1-DE7814C739C1}"/>
+                <a16:creationId xmlns:a16="http://schemas.microsoft.com/office/drawing/2014/main" id="{9A88CFB5-0FF0-4A93-A163-6841B9B0E6D4}"/>
               </a:ext>
             </a:extLst>
           </p:cNvPr>
@@ -4854,7 +4854,7 @@
           <p:cNvPr id="12" name="">
             <a:extLst xmlns:a="http://schemas.openxmlformats.org/drawingml/2006/main">
               <a:ext uri="{FF2B5EF4-FFF2-40B4-BE49-F238E27FC236}">
-                <a16:creationId xmlns:a16="http://schemas.microsoft.com/office/drawing/2014/main" id="{3908D7C7-657F-4BBA-B050-239CACD92DA5}"/>
+                <a16:creationId xmlns:a16="http://schemas.microsoft.com/office/drawing/2014/main" id="{F8DD87C1-3BBD-4499-B95B-A3209987C1FB}"/>
               </a:ext>
             </a:extLst>
           </p:cNvPr>
@@ -4911,7 +4911,7 @@
           <p:cNvPr id="13" name="">
             <a:extLst xmlns:a="http://schemas.openxmlformats.org/drawingml/2006/main">
               <a:ext uri="{FF2B5EF4-FFF2-40B4-BE49-F238E27FC236}">
-                <a16:creationId xmlns:a16="http://schemas.microsoft.com/office/drawing/2014/main" id="{81890C50-F9C5-4E96-9DC0-7A5BEC3140DB}"/>
+                <a16:creationId xmlns:a16="http://schemas.microsoft.com/office/drawing/2014/main" id="{76423E58-8F67-46F0-B964-7809F0EA9188}"/>
               </a:ext>
             </a:extLst>
           </p:cNvPr>
@@ -4968,7 +4968,7 @@
           <p:cNvPr id="14" name="">
             <a:extLst xmlns:a="http://schemas.openxmlformats.org/drawingml/2006/main">
               <a:ext uri="{FF2B5EF4-FFF2-40B4-BE49-F238E27FC236}">
-                <a16:creationId xmlns:a16="http://schemas.microsoft.com/office/drawing/2014/main" id="{8F385C77-C7B8-49C7-A322-6D3B49310B32}"/>
+                <a16:creationId xmlns:a16="http://schemas.microsoft.com/office/drawing/2014/main" id="{9FEB8677-1688-436B-87C2-0E7DFC7B590B}"/>
               </a:ext>
             </a:extLst>
           </p:cNvPr>
@@ -5002,7 +5002,7 @@
           <p:cNvPr id="15" name="">
             <a:extLst xmlns:a="http://schemas.openxmlformats.org/drawingml/2006/main">
               <a:ext uri="{FF2B5EF4-FFF2-40B4-BE49-F238E27FC236}">
-                <a16:creationId xmlns:a16="http://schemas.microsoft.com/office/drawing/2014/main" id="{5DC5CC51-504D-4C99-8AF5-F65C57308CEF}"/>
+                <a16:creationId xmlns:a16="http://schemas.microsoft.com/office/drawing/2014/main" id="{3345A964-4BCD-4BC3-BB01-9668FF5EBFE7}"/>
               </a:ext>
             </a:extLst>
           </p:cNvPr>
@@ -5034,7 +5034,7 @@
           <p:cNvPr id="16" name="">
             <a:extLst xmlns:a="http://schemas.openxmlformats.org/drawingml/2006/main">
               <a:ext uri="{FF2B5EF4-FFF2-40B4-BE49-F238E27FC236}">
-                <a16:creationId xmlns:a16="http://schemas.microsoft.com/office/drawing/2014/main" id="{4AA2B7DE-7D74-4DF4-A128-453271B6D57D}"/>
+                <a16:creationId xmlns:a16="http://schemas.microsoft.com/office/drawing/2014/main" id="{DC474898-D7FB-4426-9F77-A23F60A34341}"/>
               </a:ext>
             </a:extLst>
           </p:cNvPr>
@@ -5091,7 +5091,7 @@
           <p:cNvPr id="17" name="">
             <a:extLst xmlns:a="http://schemas.openxmlformats.org/drawingml/2006/main">
               <a:ext uri="{FF2B5EF4-FFF2-40B4-BE49-F238E27FC236}">
-                <a16:creationId xmlns:a16="http://schemas.microsoft.com/office/drawing/2014/main" id="{13570541-9D6B-48C6-8F81-703B5E170A96}"/>
+                <a16:creationId xmlns:a16="http://schemas.microsoft.com/office/drawing/2014/main" id="{028BF9B3-BB57-40DA-B959-0AF1F3BA31CE}"/>
               </a:ext>
             </a:extLst>
           </p:cNvPr>
@@ -5148,7 +5148,7 @@
           <p:cNvPr id="18" name="">
             <a:extLst xmlns:a="http://schemas.openxmlformats.org/drawingml/2006/main">
               <a:ext uri="{FF2B5EF4-FFF2-40B4-BE49-F238E27FC236}">
-                <a16:creationId xmlns:a16="http://schemas.microsoft.com/office/drawing/2014/main" id="{67ED4FD4-8570-479A-96D4-190217FF38F8}"/>
+                <a16:creationId xmlns:a16="http://schemas.microsoft.com/office/drawing/2014/main" id="{F609D651-39DE-414D-AF17-ABD4A99FCA14}"/>
               </a:ext>
             </a:extLst>
           </p:cNvPr>
@@ -5182,7 +5182,7 @@
           <p:cNvPr id="19" name="">
             <a:extLst xmlns:a="http://schemas.openxmlformats.org/drawingml/2006/main">
               <a:ext uri="{FF2B5EF4-FFF2-40B4-BE49-F238E27FC236}">
-                <a16:creationId xmlns:a16="http://schemas.microsoft.com/office/drawing/2014/main" id="{421199FB-66AD-4775-BEDC-7D290DB2E816}"/>
+                <a16:creationId xmlns:a16="http://schemas.microsoft.com/office/drawing/2014/main" id="{5DDFFFBC-A637-426D-A22D-EE6F56B27A10}"/>
               </a:ext>
             </a:extLst>
           </p:cNvPr>
@@ -5214,7 +5214,7 @@
           <p:cNvPr id="20" name="">
             <a:extLst xmlns:a="http://schemas.openxmlformats.org/drawingml/2006/main">
               <a:ext uri="{FF2B5EF4-FFF2-40B4-BE49-F238E27FC236}">
-                <a16:creationId xmlns:a16="http://schemas.microsoft.com/office/drawing/2014/main" id="{133DFE05-5C11-43E0-8344-FA1828E57832}"/>
+                <a16:creationId xmlns:a16="http://schemas.microsoft.com/office/drawing/2014/main" id="{9B88DE68-84B4-4658-95DF-062E8A97F153}"/>
               </a:ext>
             </a:extLst>
           </p:cNvPr>
@@ -5271,7 +5271,7 @@
           <p:cNvPr id="21" name="">
             <a:extLst xmlns:a="http://schemas.openxmlformats.org/drawingml/2006/main">
               <a:ext uri="{FF2B5EF4-FFF2-40B4-BE49-F238E27FC236}">
-                <a16:creationId xmlns:a16="http://schemas.microsoft.com/office/drawing/2014/main" id="{4413656C-3A58-4FDE-97C0-BD346DC825AE}"/>
+                <a16:creationId xmlns:a16="http://schemas.microsoft.com/office/drawing/2014/main" id="{45A35B76-EC05-4A30-973B-8E22DDA2EA90}"/>
               </a:ext>
             </a:extLst>
           </p:cNvPr>
@@ -5328,7 +5328,7 @@
           <p:cNvPr id="22" name="">
             <a:extLst xmlns:a="http://schemas.openxmlformats.org/drawingml/2006/main">
               <a:ext uri="{FF2B5EF4-FFF2-40B4-BE49-F238E27FC236}">
-                <a16:creationId xmlns:a16="http://schemas.microsoft.com/office/drawing/2014/main" id="{C1B29417-D828-48D0-8183-7C5C2173EF05}"/>
+                <a16:creationId xmlns:a16="http://schemas.microsoft.com/office/drawing/2014/main" id="{CB3384A9-C3A9-4319-B1B4-597770E6CDB0}"/>
               </a:ext>
             </a:extLst>
           </p:cNvPr>
@@ -5383,7 +5383,7 @@
     </p:spTree>
     <p:extLst>
       <p:ext uri="{BB962C8B-B14F-4D97-AF65-F5344CB8AC3E}">
-        <p14:creationId xmlns:p14="http://schemas.microsoft.com/office/powerpoint/2010/main" val="614133135"/>
+        <p14:creationId xmlns:p14="http://schemas.microsoft.com/office/powerpoint/2010/main" val="832058421"/>
       </p:ext>
     </p:extLst>
   </p:cSld>
@@ -5584,7 +5584,7 @@
           <p:cNvPr id="23" name="">
             <a:extLst xmlns:a="http://schemas.openxmlformats.org/drawingml/2006/main">
               <a:ext uri="{FF2B5EF4-FFF2-40B4-BE49-F238E27FC236}">
-                <a16:creationId xmlns:a16="http://schemas.microsoft.com/office/drawing/2014/main" id="{3E3EE91B-21DB-4604-A4C5-CDFA89BA7ECD}"/>
+                <a16:creationId xmlns:a16="http://schemas.microsoft.com/office/drawing/2014/main" id="{5870EE4F-3A6E-4F48-872D-A3B555BF9942}"/>
               </a:ext>
             </a:extLst>
           </p:cNvPr>
@@ -5616,7 +5616,7 @@
           <p:cNvPr id="2" name="">
             <a:extLst xmlns:a="http://schemas.openxmlformats.org/drawingml/2006/main">
               <a:ext uri="{FF2B5EF4-FFF2-40B4-BE49-F238E27FC236}">
-                <a16:creationId xmlns:a16="http://schemas.microsoft.com/office/drawing/2014/main" id="{3FC78FA3-CD80-4F41-9EB9-E9EEBB915C0F}"/>
+                <a16:creationId xmlns:a16="http://schemas.microsoft.com/office/drawing/2014/main" id="{2364E2DB-1042-4B27-981F-15E10F8167D3}"/>
               </a:ext>
             </a:extLst>
           </p:cNvPr>
@@ -5673,7 +5673,7 @@
           <p:cNvPr id="3" name="">
             <a:extLst xmlns:a="http://schemas.openxmlformats.org/drawingml/2006/main">
               <a:ext uri="{FF2B5EF4-FFF2-40B4-BE49-F238E27FC236}">
-                <a16:creationId xmlns:a16="http://schemas.microsoft.com/office/drawing/2014/main" id="{87BDC0C0-2EE5-4F9A-9111-95340ADE615B}"/>
+                <a16:creationId xmlns:a16="http://schemas.microsoft.com/office/drawing/2014/main" id="{6E38ACC5-7A8D-455D-BF00-E8D674B3BF63}"/>
               </a:ext>
             </a:extLst>
           </p:cNvPr>
@@ -5705,7 +5705,7 @@
           <p:cNvPr id="4" name="">
             <a:extLst xmlns:a="http://schemas.openxmlformats.org/drawingml/2006/main">
               <a:ext uri="{FF2B5EF4-FFF2-40B4-BE49-F238E27FC236}">
-                <a16:creationId xmlns:a16="http://schemas.microsoft.com/office/drawing/2014/main" id="{14ADE503-C407-4C8A-AF5C-0037330D3F8B}"/>
+                <a16:creationId xmlns:a16="http://schemas.microsoft.com/office/drawing/2014/main" id="{9815D673-27E8-45DB-AB13-A0A5BCC666FB}"/>
               </a:ext>
             </a:extLst>
           </p:cNvPr>
@@ -5762,7 +5762,7 @@
           <p:cNvPr id="5" name="">
             <a:extLst xmlns:a="http://schemas.openxmlformats.org/drawingml/2006/main">
               <a:ext uri="{FF2B5EF4-FFF2-40B4-BE49-F238E27FC236}">
-                <a16:creationId xmlns:a16="http://schemas.microsoft.com/office/drawing/2014/main" id="{CBEFC114-D736-43D7-9454-01C1E07615AF}"/>
+                <a16:creationId xmlns:a16="http://schemas.microsoft.com/office/drawing/2014/main" id="{98BEBEE3-BB9C-49EE-9905-4D5120BA6943}"/>
               </a:ext>
             </a:extLst>
           </p:cNvPr>
@@ -5819,7 +5819,7 @@
           <p:cNvPr id="6" name="">
             <a:extLst xmlns:a="http://schemas.openxmlformats.org/drawingml/2006/main">
               <a:ext uri="{FF2B5EF4-FFF2-40B4-BE49-F238E27FC236}">
-                <a16:creationId xmlns:a16="http://schemas.microsoft.com/office/drawing/2014/main" id="{8A7BA0A9-AD1D-4B28-8F71-02B609873A25}"/>
+                <a16:creationId xmlns:a16="http://schemas.microsoft.com/office/drawing/2014/main" id="{CF9ABE86-8187-48A2-9AF6-43F91305AF74}"/>
               </a:ext>
             </a:extLst>
           </p:cNvPr>
@@ -5876,7 +5876,7 @@
           <p:cNvPr id="7" name="">
             <a:extLst xmlns:a="http://schemas.openxmlformats.org/drawingml/2006/main">
               <a:ext uri="{FF2B5EF4-FFF2-40B4-BE49-F238E27FC236}">
-                <a16:creationId xmlns:a16="http://schemas.microsoft.com/office/drawing/2014/main" id="{8164B055-8DA1-47FE-A7F9-D519D994DE52}"/>
+                <a16:creationId xmlns:a16="http://schemas.microsoft.com/office/drawing/2014/main" id="{0909BA47-C2AA-40F3-BB14-739041070CBE}"/>
               </a:ext>
             </a:extLst>
           </p:cNvPr>
@@ -5908,7 +5908,7 @@
           <p:cNvPr id="8" name="">
             <a:extLst xmlns:a="http://schemas.openxmlformats.org/drawingml/2006/main">
               <a:ext uri="{FF2B5EF4-FFF2-40B4-BE49-F238E27FC236}">
-                <a16:creationId xmlns:a16="http://schemas.microsoft.com/office/drawing/2014/main" id="{AD77EEBC-F749-4DF5-B360-C619151E5CA5}"/>
+                <a16:creationId xmlns:a16="http://schemas.microsoft.com/office/drawing/2014/main" id="{DDAB134F-E5A0-495B-8B8E-5C872DEDDD84}"/>
               </a:ext>
             </a:extLst>
           </p:cNvPr>
@@ -5965,7 +5965,7 @@
           <p:cNvPr id="9" name="">
             <a:extLst xmlns:a="http://schemas.openxmlformats.org/drawingml/2006/main">
               <a:ext uri="{FF2B5EF4-FFF2-40B4-BE49-F238E27FC236}">
-                <a16:creationId xmlns:a16="http://schemas.microsoft.com/office/drawing/2014/main" id="{0F473D1A-7CE8-4A76-A9E3-B3F173D3814C}"/>
+                <a16:creationId xmlns:a16="http://schemas.microsoft.com/office/drawing/2014/main" id="{1EDC4489-7C85-4F3E-9D10-C11760A1EFD3}"/>
               </a:ext>
             </a:extLst>
           </p:cNvPr>
@@ -6022,7 +6022,7 @@
           <p:cNvPr id="10" name="">
             <a:extLst xmlns:a="http://schemas.openxmlformats.org/drawingml/2006/main">
               <a:ext uri="{FF2B5EF4-FFF2-40B4-BE49-F238E27FC236}">
-                <a16:creationId xmlns:a16="http://schemas.microsoft.com/office/drawing/2014/main" id="{BC34CB8C-C531-4B47-B4D9-CFC1BDF2E783}"/>
+                <a16:creationId xmlns:a16="http://schemas.microsoft.com/office/drawing/2014/main" id="{9F53F8D6-B658-4EDE-BC91-293AC56DB096}"/>
               </a:ext>
             </a:extLst>
           </p:cNvPr>
@@ -6056,7 +6056,7 @@
           <p:cNvPr id="11" name="">
             <a:extLst xmlns:a="http://schemas.openxmlformats.org/drawingml/2006/main">
               <a:ext uri="{FF2B5EF4-FFF2-40B4-BE49-F238E27FC236}">
-                <a16:creationId xmlns:a16="http://schemas.microsoft.com/office/drawing/2014/main" id="{6ECB116D-B520-48EC-A564-5526DA9D7CE5}"/>
+                <a16:creationId xmlns:a16="http://schemas.microsoft.com/office/drawing/2014/main" id="{C3AC97CA-581C-47F0-AF4C-769B9471C80E}"/>
               </a:ext>
             </a:extLst>
           </p:cNvPr>
@@ -6088,7 +6088,7 @@
           <p:cNvPr id="12" name="">
             <a:extLst xmlns:a="http://schemas.openxmlformats.org/drawingml/2006/main">
               <a:ext uri="{FF2B5EF4-FFF2-40B4-BE49-F238E27FC236}">
-                <a16:creationId xmlns:a16="http://schemas.microsoft.com/office/drawing/2014/main" id="{AADAD0A3-356B-4EB4-9D93-C007B839E965}"/>
+                <a16:creationId xmlns:a16="http://schemas.microsoft.com/office/drawing/2014/main" id="{B57C249F-062F-41E4-8E98-539611F9B531}"/>
               </a:ext>
             </a:extLst>
           </p:cNvPr>
@@ -6145,7 +6145,7 @@
           <p:cNvPr id="13" name="">
             <a:extLst xmlns:a="http://schemas.openxmlformats.org/drawingml/2006/main">
               <a:ext uri="{FF2B5EF4-FFF2-40B4-BE49-F238E27FC236}">
-                <a16:creationId xmlns:a16="http://schemas.microsoft.com/office/drawing/2014/main" id="{6E8073A5-D886-49BB-B49E-4EC975B59149}"/>
+                <a16:creationId xmlns:a16="http://schemas.microsoft.com/office/drawing/2014/main" id="{30059E6C-A8AB-4D7F-8B50-3FADBE7383E6}"/>
               </a:ext>
             </a:extLst>
           </p:cNvPr>
@@ -6202,7 +6202,7 @@
           <p:cNvPr id="14" name="">
             <a:extLst xmlns:a="http://schemas.openxmlformats.org/drawingml/2006/main">
               <a:ext uri="{FF2B5EF4-FFF2-40B4-BE49-F238E27FC236}">
-                <a16:creationId xmlns:a16="http://schemas.microsoft.com/office/drawing/2014/main" id="{4641259B-E082-408C-B854-F7F4E33106BD}"/>
+                <a16:creationId xmlns:a16="http://schemas.microsoft.com/office/drawing/2014/main" id="{41FD4E05-347C-45D4-812A-5F36B4E660C5}"/>
               </a:ext>
             </a:extLst>
           </p:cNvPr>
@@ -6236,7 +6236,7 @@
           <p:cNvPr id="15" name="">
             <a:extLst xmlns:a="http://schemas.openxmlformats.org/drawingml/2006/main">
               <a:ext uri="{FF2B5EF4-FFF2-40B4-BE49-F238E27FC236}">
-                <a16:creationId xmlns:a16="http://schemas.microsoft.com/office/drawing/2014/main" id="{92D7EA12-215B-484A-B8F0-AD94D76D642F}"/>
+                <a16:creationId xmlns:a16="http://schemas.microsoft.com/office/drawing/2014/main" id="{5E4FA09C-B684-4084-83F5-6E9E2FC6F1E6}"/>
               </a:ext>
             </a:extLst>
           </p:cNvPr>
@@ -6268,7 +6268,7 @@
           <p:cNvPr id="16" name="">
             <a:extLst xmlns:a="http://schemas.openxmlformats.org/drawingml/2006/main">
               <a:ext uri="{FF2B5EF4-FFF2-40B4-BE49-F238E27FC236}">
-                <a16:creationId xmlns:a16="http://schemas.microsoft.com/office/drawing/2014/main" id="{99D14669-F746-4251-B766-B8B2EDEF9312}"/>
+                <a16:creationId xmlns:a16="http://schemas.microsoft.com/office/drawing/2014/main" id="{28F0ADCF-7D3E-4237-A8D9-8E3F9F8416DC}"/>
               </a:ext>
             </a:extLst>
           </p:cNvPr>
@@ -6325,7 +6325,7 @@
           <p:cNvPr id="17" name="">
             <a:extLst xmlns:a="http://schemas.openxmlformats.org/drawingml/2006/main">
               <a:ext uri="{FF2B5EF4-FFF2-40B4-BE49-F238E27FC236}">
-                <a16:creationId xmlns:a16="http://schemas.microsoft.com/office/drawing/2014/main" id="{1389331A-69FF-420D-94B7-A5A9C3D52FD8}"/>
+                <a16:creationId xmlns:a16="http://schemas.microsoft.com/office/drawing/2014/main" id="{28580C24-36C3-416C-A7EF-D669685D1277}"/>
               </a:ext>
             </a:extLst>
           </p:cNvPr>
@@ -6382,7 +6382,7 @@
           <p:cNvPr id="18" name="">
             <a:extLst xmlns:a="http://schemas.openxmlformats.org/drawingml/2006/main">
               <a:ext uri="{FF2B5EF4-FFF2-40B4-BE49-F238E27FC236}">
-                <a16:creationId xmlns:a16="http://schemas.microsoft.com/office/drawing/2014/main" id="{CC5E61A7-C6A6-44C2-AA6F-E8A0C3ECD903}"/>
+                <a16:creationId xmlns:a16="http://schemas.microsoft.com/office/drawing/2014/main" id="{D5D2753B-5CBA-422D-8CB9-F2D69D2F481D}"/>
               </a:ext>
             </a:extLst>
           </p:cNvPr>
@@ -6416,7 +6416,7 @@
           <p:cNvPr id="19" name="">
             <a:extLst xmlns:a="http://schemas.openxmlformats.org/drawingml/2006/main">
               <a:ext uri="{FF2B5EF4-FFF2-40B4-BE49-F238E27FC236}">
-                <a16:creationId xmlns:a16="http://schemas.microsoft.com/office/drawing/2014/main" id="{B52AAB05-EAF6-46CF-AD19-EC55341B3C61}"/>
+                <a16:creationId xmlns:a16="http://schemas.microsoft.com/office/drawing/2014/main" id="{CBCAB59E-03BF-48C3-BD69-130E48619195}"/>
               </a:ext>
             </a:extLst>
           </p:cNvPr>
@@ -6448,7 +6448,7 @@
           <p:cNvPr id="20" name="">
             <a:extLst xmlns:a="http://schemas.openxmlformats.org/drawingml/2006/main">
               <a:ext uri="{FF2B5EF4-FFF2-40B4-BE49-F238E27FC236}">
-                <a16:creationId xmlns:a16="http://schemas.microsoft.com/office/drawing/2014/main" id="{9EA79C86-9A9B-4FDA-8328-B32E2B3213F4}"/>
+                <a16:creationId xmlns:a16="http://schemas.microsoft.com/office/drawing/2014/main" id="{ABD0A130-F8D6-49AD-9E7F-967CB1C5EC7F}"/>
               </a:ext>
             </a:extLst>
           </p:cNvPr>
@@ -6505,7 +6505,7 @@
           <p:cNvPr id="21" name="">
             <a:extLst xmlns:a="http://schemas.openxmlformats.org/drawingml/2006/main">
               <a:ext uri="{FF2B5EF4-FFF2-40B4-BE49-F238E27FC236}">
-                <a16:creationId xmlns:a16="http://schemas.microsoft.com/office/drawing/2014/main" id="{DB2CD7C8-3EE0-4166-A2CD-29662EAD6F75}"/>
+                <a16:creationId xmlns:a16="http://schemas.microsoft.com/office/drawing/2014/main" id="{AAC801B1-DFDC-4B6A-BDCF-41A926BD349E}"/>
               </a:ext>
             </a:extLst>
           </p:cNvPr>
@@ -6562,7 +6562,7 @@
           <p:cNvPr id="22" name="">
             <a:extLst xmlns:a="http://schemas.openxmlformats.org/drawingml/2006/main">
               <a:ext uri="{FF2B5EF4-FFF2-40B4-BE49-F238E27FC236}">
-                <a16:creationId xmlns:a16="http://schemas.microsoft.com/office/drawing/2014/main" id="{5571BC63-26D4-4E2C-810F-996FCC080807}"/>
+                <a16:creationId xmlns:a16="http://schemas.microsoft.com/office/drawing/2014/main" id="{8446A425-C4B0-41C1-9A61-9555796B0DE5}"/>
               </a:ext>
             </a:extLst>
           </p:cNvPr>
@@ -6617,7 +6617,7 @@
     </p:spTree>
     <p:extLst>
       <p:ext uri="{BB962C8B-B14F-4D97-AF65-F5344CB8AC3E}">
-        <p14:creationId xmlns:p14="http://schemas.microsoft.com/office/powerpoint/2010/main" val="1071507626"/>
+        <p14:creationId xmlns:p14="http://schemas.microsoft.com/office/powerpoint/2010/main" val="1949114060"/>
       </p:ext>
     </p:extLst>
   </p:cSld>
@@ -6818,7 +6818,7 @@
           <p:cNvPr id="16" name="">
             <a:extLst xmlns:a="http://schemas.openxmlformats.org/drawingml/2006/main">
               <a:ext uri="{FF2B5EF4-FFF2-40B4-BE49-F238E27FC236}">
-                <a16:creationId xmlns:a16="http://schemas.microsoft.com/office/drawing/2014/main" id="{CD9D46C7-1E93-400A-B19E-20E7C0938124}"/>
+                <a16:creationId xmlns:a16="http://schemas.microsoft.com/office/drawing/2014/main" id="{FBD7CF8A-11A0-4403-B532-F9B75A364022}"/>
               </a:ext>
             </a:extLst>
           </p:cNvPr>
@@ -6850,7 +6850,7 @@
           <p:cNvPr id="2" name="">
             <a:extLst xmlns:a="http://schemas.openxmlformats.org/drawingml/2006/main">
               <a:ext uri="{FF2B5EF4-FFF2-40B4-BE49-F238E27FC236}">
-                <a16:creationId xmlns:a16="http://schemas.microsoft.com/office/drawing/2014/main" id="{E04FAB59-EDB3-4F84-8212-1BC263FAA8D2}"/>
+                <a16:creationId xmlns:a16="http://schemas.microsoft.com/office/drawing/2014/main" id="{B6EB6831-2503-441E-90B0-55C2C6D935C6}"/>
               </a:ext>
             </a:extLst>
           </p:cNvPr>
@@ -6907,7 +6907,7 @@
           <p:cNvPr id="3" name="">
             <a:extLst xmlns:a="http://schemas.openxmlformats.org/drawingml/2006/main">
               <a:ext uri="{FF2B5EF4-FFF2-40B4-BE49-F238E27FC236}">
-                <a16:creationId xmlns:a16="http://schemas.microsoft.com/office/drawing/2014/main" id="{945D8A9C-029A-42BB-9354-1D4B807C5C48}"/>
+                <a16:creationId xmlns:a16="http://schemas.microsoft.com/office/drawing/2014/main" id="{CF2A3789-0DB5-468D-A23E-98EB87212133}"/>
               </a:ext>
             </a:extLst>
           </p:cNvPr>
@@ -6939,7 +6939,7 @@
           <p:cNvPr id="4" name="">
             <a:extLst xmlns:a="http://schemas.openxmlformats.org/drawingml/2006/main">
               <a:ext uri="{FF2B5EF4-FFF2-40B4-BE49-F238E27FC236}">
-                <a16:creationId xmlns:a16="http://schemas.microsoft.com/office/drawing/2014/main" id="{E00B17C9-4FC0-4A23-95E8-2636CA28C51A}"/>
+                <a16:creationId xmlns:a16="http://schemas.microsoft.com/office/drawing/2014/main" id="{D794C0DE-08A5-4ED1-BD65-C624F414A461}"/>
               </a:ext>
             </a:extLst>
           </p:cNvPr>
@@ -6996,7 +6996,7 @@
           <p:cNvPr id="5" name="">
             <a:extLst xmlns:a="http://schemas.openxmlformats.org/drawingml/2006/main">
               <a:ext uri="{FF2B5EF4-FFF2-40B4-BE49-F238E27FC236}">
-                <a16:creationId xmlns:a16="http://schemas.microsoft.com/office/drawing/2014/main" id="{8567B570-8145-4F39-9735-07E7F97718EB}"/>
+                <a16:creationId xmlns:a16="http://schemas.microsoft.com/office/drawing/2014/main" id="{8329880F-C5C2-4505-BBFF-9AD39158FD68}"/>
               </a:ext>
             </a:extLst>
           </p:cNvPr>
@@ -7053,7 +7053,7 @@
           <p:cNvPr id="6" name="">
             <a:extLst xmlns:a="http://schemas.openxmlformats.org/drawingml/2006/main">
               <a:ext uri="{FF2B5EF4-FFF2-40B4-BE49-F238E27FC236}">
-                <a16:creationId xmlns:a16="http://schemas.microsoft.com/office/drawing/2014/main" id="{31172E7E-2B4D-4000-9174-1086B27F2161}"/>
+                <a16:creationId xmlns:a16="http://schemas.microsoft.com/office/drawing/2014/main" id="{84DD6ABB-4036-4A09-9C6D-CCDBFB7CE0E7}"/>
               </a:ext>
             </a:extLst>
           </p:cNvPr>
@@ -7110,7 +7110,7 @@
           <p:cNvPr id="7" name="">
             <a:extLst xmlns:a="http://schemas.openxmlformats.org/drawingml/2006/main">
               <a:ext uri="{FF2B5EF4-FFF2-40B4-BE49-F238E27FC236}">
-                <a16:creationId xmlns:a16="http://schemas.microsoft.com/office/drawing/2014/main" id="{78505CC2-D387-44FE-9C2B-919418A967C5}"/>
+                <a16:creationId xmlns:a16="http://schemas.microsoft.com/office/drawing/2014/main" id="{94ED07F2-E1C3-4236-8487-D8F003041ED1}"/>
               </a:ext>
             </a:extLst>
           </p:cNvPr>
@@ -7142,7 +7142,7 @@
           <p:cNvPr id="8" name="">
             <a:extLst xmlns:a="http://schemas.openxmlformats.org/drawingml/2006/main">
               <a:ext uri="{FF2B5EF4-FFF2-40B4-BE49-F238E27FC236}">
-                <a16:creationId xmlns:a16="http://schemas.microsoft.com/office/drawing/2014/main" id="{9906B92B-ADEB-41BC-9E0A-A87449D0839F}"/>
+                <a16:creationId xmlns:a16="http://schemas.microsoft.com/office/drawing/2014/main" id="{23EFB0CC-2610-496C-87ED-20293F96B8FB}"/>
               </a:ext>
             </a:extLst>
           </p:cNvPr>
@@ -7199,7 +7199,7 @@
           <p:cNvPr id="9" name="">
             <a:extLst xmlns:a="http://schemas.openxmlformats.org/drawingml/2006/main">
               <a:ext uri="{FF2B5EF4-FFF2-40B4-BE49-F238E27FC236}">
-                <a16:creationId xmlns:a16="http://schemas.microsoft.com/office/drawing/2014/main" id="{AFB77402-35C6-46B1-B151-F242DA0E4D55}"/>
+                <a16:creationId xmlns:a16="http://schemas.microsoft.com/office/drawing/2014/main" id="{FFD6C046-87A9-43B9-B723-64913322EDEE}"/>
               </a:ext>
             </a:extLst>
           </p:cNvPr>
@@ -7256,7 +7256,7 @@
           <p:cNvPr id="10" name="">
             <a:extLst xmlns:a="http://schemas.openxmlformats.org/drawingml/2006/main">
               <a:ext uri="{FF2B5EF4-FFF2-40B4-BE49-F238E27FC236}">
-                <a16:creationId xmlns:a16="http://schemas.microsoft.com/office/drawing/2014/main" id="{F1009B77-7A06-42C5-AD2F-CAACB0780092}"/>
+                <a16:creationId xmlns:a16="http://schemas.microsoft.com/office/drawing/2014/main" id="{0550B203-F311-4720-AEED-900E1D2CA89E}"/>
               </a:ext>
             </a:extLst>
           </p:cNvPr>
@@ -7313,7 +7313,7 @@
           <p:cNvPr id="11" name="">
             <a:extLst xmlns:a="http://schemas.openxmlformats.org/drawingml/2006/main">
               <a:ext uri="{FF2B5EF4-FFF2-40B4-BE49-F238E27FC236}">
-                <a16:creationId xmlns:a16="http://schemas.microsoft.com/office/drawing/2014/main" id="{BF3457C7-111E-42F3-AD28-25128AF29E0D}"/>
+                <a16:creationId xmlns:a16="http://schemas.microsoft.com/office/drawing/2014/main" id="{9E740299-52D7-487A-802E-FBCC1167C613}"/>
               </a:ext>
             </a:extLst>
           </p:cNvPr>
@@ -7345,7 +7345,7 @@
           <p:cNvPr id="12" name="">
             <a:extLst xmlns:a="http://schemas.openxmlformats.org/drawingml/2006/main">
               <a:ext uri="{FF2B5EF4-FFF2-40B4-BE49-F238E27FC236}">
-                <a16:creationId xmlns:a16="http://schemas.microsoft.com/office/drawing/2014/main" id="{C5B5EC76-4B15-4E95-A51E-1ECD02A5144D}"/>
+                <a16:creationId xmlns:a16="http://schemas.microsoft.com/office/drawing/2014/main" id="{8A264BA2-0704-411F-B0EC-E8518C9A7CB2}"/>
               </a:ext>
             </a:extLst>
           </p:cNvPr>
@@ -7402,7 +7402,7 @@
           <p:cNvPr id="13" name="">
             <a:extLst xmlns:a="http://schemas.openxmlformats.org/drawingml/2006/main">
               <a:ext uri="{FF2B5EF4-FFF2-40B4-BE49-F238E27FC236}">
-                <a16:creationId xmlns:a16="http://schemas.microsoft.com/office/drawing/2014/main" id="{8490DEE5-BA70-49C0-8AA9-EC2A330F2D3E}"/>
+                <a16:creationId xmlns:a16="http://schemas.microsoft.com/office/drawing/2014/main" id="{6E472E50-2893-48C6-AD26-F7BB18302F45}"/>
               </a:ext>
             </a:extLst>
           </p:cNvPr>
@@ -7459,7 +7459,7 @@
           <p:cNvPr id="14" name="">
             <a:extLst xmlns:a="http://schemas.openxmlformats.org/drawingml/2006/main">
               <a:ext uri="{FF2B5EF4-FFF2-40B4-BE49-F238E27FC236}">
-                <a16:creationId xmlns:a16="http://schemas.microsoft.com/office/drawing/2014/main" id="{EEDBAF2D-14D1-4028-AC0D-BCA5DB885124}"/>
+                <a16:creationId xmlns:a16="http://schemas.microsoft.com/office/drawing/2014/main" id="{E70904FC-E840-4B4D-AA41-7FD9B780E106}"/>
               </a:ext>
             </a:extLst>
           </p:cNvPr>
@@ -7516,7 +7516,7 @@
           <p:cNvPr id="15" name="">
             <a:extLst xmlns:a="http://schemas.openxmlformats.org/drawingml/2006/main">
               <a:ext uri="{FF2B5EF4-FFF2-40B4-BE49-F238E27FC236}">
-                <a16:creationId xmlns:a16="http://schemas.microsoft.com/office/drawing/2014/main" id="{8003494E-E77F-4FA9-AA27-E56A01A41160}"/>
+                <a16:creationId xmlns:a16="http://schemas.microsoft.com/office/drawing/2014/main" id="{33995A97-E6B2-49D6-B2A6-8C6D21B5D098}"/>
               </a:ext>
             </a:extLst>
           </p:cNvPr>
@@ -7571,7 +7571,7 @@
     </p:spTree>
     <p:extLst>
       <p:ext uri="{BB962C8B-B14F-4D97-AF65-F5344CB8AC3E}">
-        <p14:creationId xmlns:p14="http://schemas.microsoft.com/office/powerpoint/2010/main" val="583430031"/>
+        <p14:creationId xmlns:p14="http://schemas.microsoft.com/office/powerpoint/2010/main" val="1121291753"/>
       </p:ext>
     </p:extLst>
   </p:cSld>
@@ -7772,7 +7772,7 @@
           <p:cNvPr id="23" name="">
             <a:extLst xmlns:a="http://schemas.openxmlformats.org/drawingml/2006/main">
               <a:ext uri="{FF2B5EF4-FFF2-40B4-BE49-F238E27FC236}">
-                <a16:creationId xmlns:a16="http://schemas.microsoft.com/office/drawing/2014/main" id="{404F85A6-9EA7-4DCF-81F1-89554304E7A2}"/>
+                <a16:creationId xmlns:a16="http://schemas.microsoft.com/office/drawing/2014/main" id="{C779F62A-216A-4E82-AB78-1E9821E67E76}"/>
               </a:ext>
             </a:extLst>
           </p:cNvPr>
@@ -7804,7 +7804,7 @@
           <p:cNvPr id="2" name="">
             <a:extLst xmlns:a="http://schemas.openxmlformats.org/drawingml/2006/main">
               <a:ext uri="{FF2B5EF4-FFF2-40B4-BE49-F238E27FC236}">
-                <a16:creationId xmlns:a16="http://schemas.microsoft.com/office/drawing/2014/main" id="{9BDA5D39-38D9-42EC-BE55-2824939AE39E}"/>
+                <a16:creationId xmlns:a16="http://schemas.microsoft.com/office/drawing/2014/main" id="{69DF91DD-6663-473B-A83B-494D74C87BB7}"/>
               </a:ext>
             </a:extLst>
           </p:cNvPr>
@@ -7861,7 +7861,7 @@
           <p:cNvPr id="3" name="">
             <a:extLst xmlns:a="http://schemas.openxmlformats.org/drawingml/2006/main">
               <a:ext uri="{FF2B5EF4-FFF2-40B4-BE49-F238E27FC236}">
-                <a16:creationId xmlns:a16="http://schemas.microsoft.com/office/drawing/2014/main" id="{F51B17C8-5566-4BA8-AF91-6CE231A0EECD}"/>
+                <a16:creationId xmlns:a16="http://schemas.microsoft.com/office/drawing/2014/main" id="{357F313D-E1E7-49BA-90E2-082465EEB713}"/>
               </a:ext>
             </a:extLst>
           </p:cNvPr>
@@ -7893,7 +7893,7 @@
           <p:cNvPr id="4" name="">
             <a:extLst xmlns:a="http://schemas.openxmlformats.org/drawingml/2006/main">
               <a:ext uri="{FF2B5EF4-FFF2-40B4-BE49-F238E27FC236}">
-                <a16:creationId xmlns:a16="http://schemas.microsoft.com/office/drawing/2014/main" id="{AF925890-DA0B-440A-9AF5-818A3C8BC255}"/>
+                <a16:creationId xmlns:a16="http://schemas.microsoft.com/office/drawing/2014/main" id="{3A3C341A-47C8-4587-8CB5-E1C833891A37}"/>
               </a:ext>
             </a:extLst>
           </p:cNvPr>
@@ -7950,7 +7950,7 @@
           <p:cNvPr id="5" name="">
             <a:extLst xmlns:a="http://schemas.openxmlformats.org/drawingml/2006/main">
               <a:ext uri="{FF2B5EF4-FFF2-40B4-BE49-F238E27FC236}">
-                <a16:creationId xmlns:a16="http://schemas.microsoft.com/office/drawing/2014/main" id="{0E25D54D-AA8D-4180-AB63-390B5BE0CD3A}"/>
+                <a16:creationId xmlns:a16="http://schemas.microsoft.com/office/drawing/2014/main" id="{0EC15D9F-CDA8-4940-989C-3DAE18D61043}"/>
               </a:ext>
             </a:extLst>
           </p:cNvPr>
@@ -8007,7 +8007,7 @@
           <p:cNvPr id="6" name="">
             <a:extLst xmlns:a="http://schemas.openxmlformats.org/drawingml/2006/main">
               <a:ext uri="{FF2B5EF4-FFF2-40B4-BE49-F238E27FC236}">
-                <a16:creationId xmlns:a16="http://schemas.microsoft.com/office/drawing/2014/main" id="{2D7B369C-2F45-4614-AB30-4E5DE16FB83D}"/>
+                <a16:creationId xmlns:a16="http://schemas.microsoft.com/office/drawing/2014/main" id="{9484589D-BEDA-46A9-9C7B-8FD6C7D6F735}"/>
               </a:ext>
             </a:extLst>
           </p:cNvPr>
@@ -8064,7 +8064,7 @@
           <p:cNvPr id="7" name="">
             <a:extLst xmlns:a="http://schemas.openxmlformats.org/drawingml/2006/main">
               <a:ext uri="{FF2B5EF4-FFF2-40B4-BE49-F238E27FC236}">
-                <a16:creationId xmlns:a16="http://schemas.microsoft.com/office/drawing/2014/main" id="{B4E79F40-912B-45E6-941E-B1E07EF66565}"/>
+                <a16:creationId xmlns:a16="http://schemas.microsoft.com/office/drawing/2014/main" id="{90732FA3-C5EF-421B-A2A3-C158384E4B26}"/>
               </a:ext>
             </a:extLst>
           </p:cNvPr>
@@ -8096,7 +8096,7 @@
           <p:cNvPr id="8" name="">
             <a:extLst xmlns:a="http://schemas.openxmlformats.org/drawingml/2006/main">
               <a:ext uri="{FF2B5EF4-FFF2-40B4-BE49-F238E27FC236}">
-                <a16:creationId xmlns:a16="http://schemas.microsoft.com/office/drawing/2014/main" id="{C6DFCF79-4775-4E7A-9D9C-7DA5FC9F6A43}"/>
+                <a16:creationId xmlns:a16="http://schemas.microsoft.com/office/drawing/2014/main" id="{114DAF33-DBD3-4EF5-88CC-A882367EB33F}"/>
               </a:ext>
             </a:extLst>
           </p:cNvPr>
@@ -8153,7 +8153,7 @@
           <p:cNvPr id="9" name="">
             <a:extLst xmlns:a="http://schemas.openxmlformats.org/drawingml/2006/main">
               <a:ext uri="{FF2B5EF4-FFF2-40B4-BE49-F238E27FC236}">
-                <a16:creationId xmlns:a16="http://schemas.microsoft.com/office/drawing/2014/main" id="{9FC2DCFA-6BDA-4E8C-AD34-8A64B6E733CF}"/>
+                <a16:creationId xmlns:a16="http://schemas.microsoft.com/office/drawing/2014/main" id="{93B5D275-2C71-496D-8608-3B5B3DBDD10F}"/>
               </a:ext>
             </a:extLst>
           </p:cNvPr>
@@ -8210,19 +8210,19 @@
           <p:cNvPr id="10" name="">
             <a:extLst xmlns:a="http://schemas.openxmlformats.org/drawingml/2006/main">
               <a:ext uri="{FF2B5EF4-FFF2-40B4-BE49-F238E27FC236}">
-                <a16:creationId xmlns:a16="http://schemas.microsoft.com/office/drawing/2014/main" id="{82CAA575-D298-41BD-8ED9-5AC05D15226C}"/>
-              </a:ext>
-            </a:extLst>
-          </p:cNvPr>
-          <p:cNvSpPr>
-            <a:spLocks xmlns:a="http://schemas.openxmlformats.org/drawingml/2006/main" noGrp="1"/>
-          </p:cNvSpPr>
-          <p:nvPr/>
-        </p:nvSpPr>
-        <p:spPr>
-          <a:xfrm xmlns:a="http://schemas.openxmlformats.org/drawingml/2006/main">
-            <a:off x="914400" y="1257300"/>
-            <a:ext cx="10363200" cy="781050"/>
+                <a16:creationId xmlns:a16="http://schemas.microsoft.com/office/drawing/2014/main" id="{0A95404E-BA4E-4B85-A2FF-8F37FE43C81E}"/>
+              </a:ext>
+            </a:extLst>
+          </p:cNvPr>
+          <p:cNvSpPr>
+            <a:spLocks xmlns:a="http://schemas.openxmlformats.org/drawingml/2006/main" noGrp="1"/>
+          </p:cNvSpPr>
+          <p:nvPr/>
+        </p:nvSpPr>
+        <p:spPr>
+          <a:xfrm xmlns:a="http://schemas.openxmlformats.org/drawingml/2006/main">
+            <a:off x="857250" y="1219200"/>
+            <a:ext cx="10477500" cy="742950"/>
           </a:xfrm>
           <a:prstGeom xmlns:a="http://schemas.openxmlformats.org/drawingml/2006/main" prst="rect">
             <a:avLst/>
@@ -8239,7 +8239,7 @@
           <a:lstStyle xmlns:a="http://schemas.openxmlformats.org/drawingml/2006/main"/>
           <a:p xmlns:a="http://schemas.openxmlformats.org/drawingml/2006/main">
             <a:pPr algn="ctr">
-              <a:defRPr sz="2175" b="1">
+              <a:defRPr sz="2100" b="1">
                 <a:solidFill>
                   <a:srgbClr val="17253A"/>
                 </a:solidFill>
@@ -8249,7 +8249,7 @@
               </a:defRPr>
             </a:pPr>
             <a:r>
-              <a:rPr sz="2175" b="1">
+              <a:rPr sz="2100" b="1">
                 <a:solidFill>
                   <a:srgbClr val="17253A"/>
                 </a:solidFill>
@@ -8267,28 +8267,30 @@
           <p:cNvPr id="11" name="">
             <a:extLst xmlns:a="http://schemas.openxmlformats.org/drawingml/2006/main">
               <a:ext uri="{FF2B5EF4-FFF2-40B4-BE49-F238E27FC236}">
-                <a16:creationId xmlns:a16="http://schemas.microsoft.com/office/drawing/2014/main" id="{ED0BDDE5-83AF-4052-96EF-7619233787D2}"/>
-              </a:ext>
-            </a:extLst>
-          </p:cNvPr>
-          <p:cNvSpPr>
-            <a:spLocks xmlns:a="http://schemas.openxmlformats.org/drawingml/2006/main" noGrp="1"/>
-          </p:cNvSpPr>
-          <p:nvPr/>
-        </p:nvSpPr>
-        <p:spPr>
-          <a:xfrm xmlns:a="http://schemas.openxmlformats.org/drawingml/2006/main">
-            <a:off x="1000125" y="2247900"/>
-            <a:ext cx="476250" cy="476250"/>
-          </a:xfrm>
-          <a:prstGeom xmlns:a="http://schemas.openxmlformats.org/drawingml/2006/main" prst="ellipse">
+                <a16:creationId xmlns:a16="http://schemas.microsoft.com/office/drawing/2014/main" id="{A24ABDE5-F882-42AB-9E17-F8A2A9DAE3BA}"/>
+              </a:ext>
+            </a:extLst>
+          </p:cNvPr>
+          <p:cNvSpPr>
+            <a:spLocks xmlns:a="http://schemas.openxmlformats.org/drawingml/2006/main" noGrp="1"/>
+          </p:cNvSpPr>
+          <p:nvPr/>
+        </p:nvSpPr>
+        <p:spPr>
+          <a:xfrm xmlns:a="http://schemas.openxmlformats.org/drawingml/2006/main">
+            <a:off x="971550" y="2124075"/>
+            <a:ext cx="38100" cy="3524250"/>
+          </a:xfrm>
+          <a:prstGeom xmlns:a="http://schemas.openxmlformats.org/drawingml/2006/main" prst="rect">
             <a:avLst/>
           </a:prstGeom>
           <a:solidFill xmlns:a="http://schemas.openxmlformats.org/drawingml/2006/main">
-            <a:srgbClr val="18324A"/>
+            <a:srgbClr val="2C6E73"/>
           </a:solidFill>
           <a:ln xmlns:a="http://schemas.openxmlformats.org/drawingml/2006/main" w="0">
-            <a:noFill/>
+            <a:solidFill>
+              <a:srgbClr val="2C6E73"/>
+            </a:solidFill>
           </a:ln>
         </p:spPr>
       </p:sp>
@@ -8297,19 +8299,19 @@
           <p:cNvPr id="12" name="">
             <a:extLst xmlns:a="http://schemas.openxmlformats.org/drawingml/2006/main">
               <a:ext uri="{FF2B5EF4-FFF2-40B4-BE49-F238E27FC236}">
-                <a16:creationId xmlns:a16="http://schemas.microsoft.com/office/drawing/2014/main" id="{24F197FD-4C87-4080-8C57-48CA66816BDD}"/>
-              </a:ext>
-            </a:extLst>
-          </p:cNvPr>
-          <p:cNvSpPr>
-            <a:spLocks xmlns:a="http://schemas.openxmlformats.org/drawingml/2006/main" noGrp="1"/>
-          </p:cNvSpPr>
-          <p:nvPr/>
-        </p:nvSpPr>
-        <p:spPr>
-          <a:xfrm xmlns:a="http://schemas.openxmlformats.org/drawingml/2006/main">
-            <a:off x="1000125" y="2276475"/>
-            <a:ext cx="476250" cy="419100"/>
+                <a16:creationId xmlns:a16="http://schemas.microsoft.com/office/drawing/2014/main" id="{DA2EB023-F7C0-4C6E-94E4-E6060AE4F83B}"/>
+              </a:ext>
+            </a:extLst>
+          </p:cNvPr>
+          <p:cNvSpPr>
+            <a:spLocks xmlns:a="http://schemas.openxmlformats.org/drawingml/2006/main" noGrp="1"/>
+          </p:cNvSpPr>
+          <p:nvPr/>
+        </p:nvSpPr>
+        <p:spPr>
+          <a:xfrm xmlns:a="http://schemas.openxmlformats.org/drawingml/2006/main">
+            <a:off x="1162050" y="2200275"/>
+            <a:ext cx="400050" cy="400050"/>
           </a:xfrm>
           <a:prstGeom xmlns:a="http://schemas.openxmlformats.org/drawingml/2006/main" prst="rect">
             <a:avLst/>
@@ -8326,9 +8328,9 @@
           <a:lstStyle xmlns:a="http://schemas.openxmlformats.org/drawingml/2006/main"/>
           <a:p xmlns:a="http://schemas.openxmlformats.org/drawingml/2006/main">
             <a:pPr algn="ctr">
-              <a:defRPr sz="1350" b="1">
-                <a:solidFill>
-                  <a:srgbClr val="FFFFFF"/>
+              <a:defRPr sz="1125" b="1">
+                <a:solidFill>
+                  <a:srgbClr val="2C6E73"/>
                 </a:solidFill>
                 <a:latin typeface="Arial"/>
                 <a:ea typeface="Arial"/>
@@ -8336,9 +8338,9 @@
               </a:defRPr>
             </a:pPr>
             <a:r>
-              <a:rPr sz="1350" b="1">
-                <a:solidFill>
-                  <a:srgbClr val="FFFFFF"/>
+              <a:rPr sz="1125" b="1">
+                <a:solidFill>
+                  <a:srgbClr val="2C6E73"/>
                 </a:solidFill>
                 <a:latin typeface="Arial"/>
                 <a:ea typeface="Arial"/>
@@ -8354,19 +8356,19 @@
           <p:cNvPr id="13" name="">
             <a:extLst xmlns:a="http://schemas.openxmlformats.org/drawingml/2006/main">
               <a:ext uri="{FF2B5EF4-FFF2-40B4-BE49-F238E27FC236}">
-                <a16:creationId xmlns:a16="http://schemas.microsoft.com/office/drawing/2014/main" id="{3E228B97-CE19-4746-9ADF-6D8F1074313E}"/>
-              </a:ext>
-            </a:extLst>
-          </p:cNvPr>
-          <p:cNvSpPr>
-            <a:spLocks xmlns:a="http://schemas.openxmlformats.org/drawingml/2006/main" noGrp="1"/>
-          </p:cNvSpPr>
-          <p:nvPr/>
-        </p:nvSpPr>
-        <p:spPr>
-          <a:xfrm xmlns:a="http://schemas.openxmlformats.org/drawingml/2006/main">
-            <a:off x="1714500" y="2181225"/>
-            <a:ext cx="9429750" cy="609600"/>
+                <a16:creationId xmlns:a16="http://schemas.microsoft.com/office/drawing/2014/main" id="{F321CEDC-B4E8-4D13-AD80-148279F1D61F}"/>
+              </a:ext>
+            </a:extLst>
+          </p:cNvPr>
+          <p:cNvSpPr>
+            <a:spLocks xmlns:a="http://schemas.openxmlformats.org/drawingml/2006/main" noGrp="1"/>
+          </p:cNvSpPr>
+          <p:nvPr/>
+        </p:nvSpPr>
+        <p:spPr>
+          <a:xfrm xmlns:a="http://schemas.openxmlformats.org/drawingml/2006/main">
+            <a:off x="1714500" y="2114550"/>
+            <a:ext cx="9525000" cy="809625"/>
           </a:xfrm>
           <a:prstGeom xmlns:a="http://schemas.openxmlformats.org/drawingml/2006/main" prst="rect">
             <a:avLst/>
@@ -8383,7 +8385,7 @@
           <a:lstStyle xmlns:a="http://schemas.openxmlformats.org/drawingml/2006/main"/>
           <a:p xmlns:a="http://schemas.openxmlformats.org/drawingml/2006/main">
             <a:pPr algn="l">
-              <a:defRPr sz="1500" b="0">
+              <a:defRPr sz="1725" b="0">
                 <a:solidFill>
                   <a:srgbClr val="17253A"/>
                 </a:solidFill>
@@ -8393,7 +8395,7 @@
               </a:defRPr>
             </a:pPr>
             <a:r>
-              <a:rPr sz="1500" b="0">
+              <a:rPr sz="1725" b="0">
                 <a:solidFill>
                   <a:srgbClr val="17253A"/>
                 </a:solidFill>
@@ -8401,7 +8403,7 @@
                 <a:ea typeface="Arial"/>
                 <a:cs typeface="Arial"/>
               </a:rPr>
-              <a:t>Identify the structure: Read the number in three-digit periods from left to right.</a:t>
+              <a:t>-4 to 0 = 4 steps</a:t>
             </a:r>
           </a:p>
         </p:txBody>
@@ -8411,28 +8413,30 @@
           <p:cNvPr id="14" name="">
             <a:extLst xmlns:a="http://schemas.openxmlformats.org/drawingml/2006/main">
               <a:ext uri="{FF2B5EF4-FFF2-40B4-BE49-F238E27FC236}">
-                <a16:creationId xmlns:a16="http://schemas.microsoft.com/office/drawing/2014/main" id="{C3CC50FA-122F-43E2-A81A-7A70AE5BE5C0}"/>
-              </a:ext>
-            </a:extLst>
-          </p:cNvPr>
-          <p:cNvSpPr>
-            <a:spLocks xmlns:a="http://schemas.openxmlformats.org/drawingml/2006/main" noGrp="1"/>
-          </p:cNvSpPr>
-          <p:nvPr/>
-        </p:nvSpPr>
-        <p:spPr>
-          <a:xfrm xmlns:a="http://schemas.openxmlformats.org/drawingml/2006/main">
-            <a:off x="1000125" y="2990850"/>
-            <a:ext cx="476250" cy="476250"/>
-          </a:xfrm>
-          <a:prstGeom xmlns:a="http://schemas.openxmlformats.org/drawingml/2006/main" prst="ellipse">
+                <a16:creationId xmlns:a16="http://schemas.microsoft.com/office/drawing/2014/main" id="{71B050DA-1BE9-4C7A-9BA2-930A1EE208C3}"/>
+              </a:ext>
+            </a:extLst>
+          </p:cNvPr>
+          <p:cNvSpPr>
+            <a:spLocks xmlns:a="http://schemas.openxmlformats.org/drawingml/2006/main" noGrp="1"/>
+          </p:cNvSpPr>
+          <p:nvPr/>
+        </p:nvSpPr>
+        <p:spPr>
+          <a:xfrm xmlns:a="http://schemas.openxmlformats.org/drawingml/2006/main">
+            <a:off x="1714500" y="2943225"/>
+            <a:ext cx="9334500" cy="9525"/>
+          </a:xfrm>
+          <a:prstGeom xmlns:a="http://schemas.openxmlformats.org/drawingml/2006/main" prst="rect">
             <a:avLst/>
           </a:prstGeom>
           <a:solidFill xmlns:a="http://schemas.openxmlformats.org/drawingml/2006/main">
-            <a:srgbClr val="2C6E73"/>
+            <a:srgbClr val="D9E0E6"/>
           </a:solidFill>
           <a:ln xmlns:a="http://schemas.openxmlformats.org/drawingml/2006/main" w="0">
-            <a:noFill/>
+            <a:solidFill>
+              <a:srgbClr val="D9E0E6"/>
+            </a:solidFill>
           </a:ln>
         </p:spPr>
       </p:sp>
@@ -8441,19 +8445,19 @@
           <p:cNvPr id="15" name="">
             <a:extLst xmlns:a="http://schemas.openxmlformats.org/drawingml/2006/main">
               <a:ext uri="{FF2B5EF4-FFF2-40B4-BE49-F238E27FC236}">
-                <a16:creationId xmlns:a16="http://schemas.microsoft.com/office/drawing/2014/main" id="{BA94D09D-D390-4AA6-9E6C-65A41112BB26}"/>
-              </a:ext>
-            </a:extLst>
-          </p:cNvPr>
-          <p:cNvSpPr>
-            <a:spLocks xmlns:a="http://schemas.openxmlformats.org/drawingml/2006/main" noGrp="1"/>
-          </p:cNvSpPr>
-          <p:nvPr/>
-        </p:nvSpPr>
-        <p:spPr>
-          <a:xfrm xmlns:a="http://schemas.openxmlformats.org/drawingml/2006/main">
-            <a:off x="1000125" y="3019425"/>
-            <a:ext cx="476250" cy="419100"/>
+                <a16:creationId xmlns:a16="http://schemas.microsoft.com/office/drawing/2014/main" id="{0668F9DE-E18A-4E9F-B243-70EB49ED164D}"/>
+              </a:ext>
+            </a:extLst>
+          </p:cNvPr>
+          <p:cNvSpPr>
+            <a:spLocks xmlns:a="http://schemas.openxmlformats.org/drawingml/2006/main" noGrp="1"/>
+          </p:cNvSpPr>
+          <p:nvPr/>
+        </p:nvSpPr>
+        <p:spPr>
+          <a:xfrm xmlns:a="http://schemas.openxmlformats.org/drawingml/2006/main">
+            <a:off x="1162050" y="3076575"/>
+            <a:ext cx="400050" cy="400050"/>
           </a:xfrm>
           <a:prstGeom xmlns:a="http://schemas.openxmlformats.org/drawingml/2006/main" prst="rect">
             <a:avLst/>
@@ -8470,9 +8474,9 @@
           <a:lstStyle xmlns:a="http://schemas.openxmlformats.org/drawingml/2006/main"/>
           <a:p xmlns:a="http://schemas.openxmlformats.org/drawingml/2006/main">
             <a:pPr algn="ctr">
-              <a:defRPr sz="1350" b="1">
-                <a:solidFill>
-                  <a:srgbClr val="FFFFFF"/>
+              <a:defRPr sz="1125" b="1">
+                <a:solidFill>
+                  <a:srgbClr val="2C6E73"/>
                 </a:solidFill>
                 <a:latin typeface="Arial"/>
                 <a:ea typeface="Arial"/>
@@ -8480,9 +8484,9 @@
               </a:defRPr>
             </a:pPr>
             <a:r>
-              <a:rPr sz="1350" b="1">
-                <a:solidFill>
-                  <a:srgbClr val="FFFFFF"/>
+              <a:rPr sz="1125" b="1">
+                <a:solidFill>
+                  <a:srgbClr val="2C6E73"/>
                 </a:solidFill>
                 <a:latin typeface="Arial"/>
                 <a:ea typeface="Arial"/>
@@ -8498,19 +8502,19 @@
           <p:cNvPr id="16" name="">
             <a:extLst xmlns:a="http://schemas.openxmlformats.org/drawingml/2006/main">
               <a:ext uri="{FF2B5EF4-FFF2-40B4-BE49-F238E27FC236}">
-                <a16:creationId xmlns:a16="http://schemas.microsoft.com/office/drawing/2014/main" id="{69BAEEEB-2A68-4836-9C6A-CF458572C7FB}"/>
-              </a:ext>
-            </a:extLst>
-          </p:cNvPr>
-          <p:cNvSpPr>
-            <a:spLocks xmlns:a="http://schemas.openxmlformats.org/drawingml/2006/main" noGrp="1"/>
-          </p:cNvSpPr>
-          <p:nvPr/>
-        </p:nvSpPr>
-        <p:spPr>
-          <a:xfrm xmlns:a="http://schemas.openxmlformats.org/drawingml/2006/main">
-            <a:off x="1714500" y="2924175"/>
-            <a:ext cx="9429750" cy="609600"/>
+                <a16:creationId xmlns:a16="http://schemas.microsoft.com/office/drawing/2014/main" id="{80132119-97E1-4F22-829A-3366344EFD9C}"/>
+              </a:ext>
+            </a:extLst>
+          </p:cNvPr>
+          <p:cNvSpPr>
+            <a:spLocks xmlns:a="http://schemas.openxmlformats.org/drawingml/2006/main" noGrp="1"/>
+          </p:cNvSpPr>
+          <p:nvPr/>
+        </p:nvSpPr>
+        <p:spPr>
+          <a:xfrm xmlns:a="http://schemas.openxmlformats.org/drawingml/2006/main">
+            <a:off x="1714500" y="2990850"/>
+            <a:ext cx="9525000" cy="809625"/>
           </a:xfrm>
           <a:prstGeom xmlns:a="http://schemas.openxmlformats.org/drawingml/2006/main" prst="rect">
             <a:avLst/>
@@ -8527,7 +8531,7 @@
           <a:lstStyle xmlns:a="http://schemas.openxmlformats.org/drawingml/2006/main"/>
           <a:p xmlns:a="http://schemas.openxmlformats.org/drawingml/2006/main">
             <a:pPr algn="l">
-              <a:defRPr sz="1500" b="0">
+              <a:defRPr sz="1725" b="0">
                 <a:solidFill>
                   <a:srgbClr val="17253A"/>
                 </a:solidFill>
@@ -8537,7 +8541,7 @@
               </a:defRPr>
             </a:pPr>
             <a:r>
-              <a:rPr sz="1500" b="0">
+              <a:rPr sz="1725" b="0">
                 <a:solidFill>
                   <a:srgbClr val="17253A"/>
                 </a:solidFill>
@@ -8545,7 +8549,7 @@
                 <a:ea typeface="Arial"/>
                 <a:cs typeface="Arial"/>
               </a:rPr>
-              <a:t>Set up the method: Record each digit in the correct place-value column.</a:t>
+              <a:t>0 to 7 = 7 steps</a:t>
             </a:r>
           </a:p>
         </p:txBody>
@@ -8555,28 +8559,30 @@
           <p:cNvPr id="17" name="">
             <a:extLst xmlns:a="http://schemas.openxmlformats.org/drawingml/2006/main">
               <a:ext uri="{FF2B5EF4-FFF2-40B4-BE49-F238E27FC236}">
-                <a16:creationId xmlns:a16="http://schemas.microsoft.com/office/drawing/2014/main" id="{C804536C-AB3A-4F69-997F-5BCCE86138FD}"/>
-              </a:ext>
-            </a:extLst>
-          </p:cNvPr>
-          <p:cNvSpPr>
-            <a:spLocks xmlns:a="http://schemas.openxmlformats.org/drawingml/2006/main" noGrp="1"/>
-          </p:cNvSpPr>
-          <p:nvPr/>
-        </p:nvSpPr>
-        <p:spPr>
-          <a:xfrm xmlns:a="http://schemas.openxmlformats.org/drawingml/2006/main">
-            <a:off x="1000125" y="3733800"/>
-            <a:ext cx="476250" cy="476250"/>
-          </a:xfrm>
-          <a:prstGeom xmlns:a="http://schemas.openxmlformats.org/drawingml/2006/main" prst="ellipse">
+                <a16:creationId xmlns:a16="http://schemas.microsoft.com/office/drawing/2014/main" id="{DDAAAAC7-7DEC-40B1-B278-BDCB834472C4}"/>
+              </a:ext>
+            </a:extLst>
+          </p:cNvPr>
+          <p:cNvSpPr>
+            <a:spLocks xmlns:a="http://schemas.openxmlformats.org/drawingml/2006/main" noGrp="1"/>
+          </p:cNvSpPr>
+          <p:nvPr/>
+        </p:nvSpPr>
+        <p:spPr>
+          <a:xfrm xmlns:a="http://schemas.openxmlformats.org/drawingml/2006/main">
+            <a:off x="1714500" y="3819525"/>
+            <a:ext cx="9334500" cy="9525"/>
+          </a:xfrm>
+          <a:prstGeom xmlns:a="http://schemas.openxmlformats.org/drawingml/2006/main" prst="rect">
             <a:avLst/>
           </a:prstGeom>
           <a:solidFill xmlns:a="http://schemas.openxmlformats.org/drawingml/2006/main">
-            <a:srgbClr val="2C6E73"/>
+            <a:srgbClr val="D9E0E6"/>
           </a:solidFill>
           <a:ln xmlns:a="http://schemas.openxmlformats.org/drawingml/2006/main" w="0">
-            <a:noFill/>
+            <a:solidFill>
+              <a:srgbClr val="D9E0E6"/>
+            </a:solidFill>
           </a:ln>
         </p:spPr>
       </p:sp>
@@ -8585,19 +8591,19 @@
           <p:cNvPr id="18" name="">
             <a:extLst xmlns:a="http://schemas.openxmlformats.org/drawingml/2006/main">
               <a:ext uri="{FF2B5EF4-FFF2-40B4-BE49-F238E27FC236}">
-                <a16:creationId xmlns:a16="http://schemas.microsoft.com/office/drawing/2014/main" id="{D0A1E4B2-066D-41F0-BA53-D68AAFE7C6DA}"/>
-              </a:ext>
-            </a:extLst>
-          </p:cNvPr>
-          <p:cNvSpPr>
-            <a:spLocks xmlns:a="http://schemas.openxmlformats.org/drawingml/2006/main" noGrp="1"/>
-          </p:cNvSpPr>
-          <p:nvPr/>
-        </p:nvSpPr>
-        <p:spPr>
-          <a:xfrm xmlns:a="http://schemas.openxmlformats.org/drawingml/2006/main">
-            <a:off x="1000125" y="3762375"/>
-            <a:ext cx="476250" cy="419100"/>
+                <a16:creationId xmlns:a16="http://schemas.microsoft.com/office/drawing/2014/main" id="{A7BBB923-16E5-4216-A457-3C82F8D5CA39}"/>
+              </a:ext>
+            </a:extLst>
+          </p:cNvPr>
+          <p:cNvSpPr>
+            <a:spLocks xmlns:a="http://schemas.openxmlformats.org/drawingml/2006/main" noGrp="1"/>
+          </p:cNvSpPr>
+          <p:nvPr/>
+        </p:nvSpPr>
+        <p:spPr>
+          <a:xfrm xmlns:a="http://schemas.openxmlformats.org/drawingml/2006/main">
+            <a:off x="1162050" y="3952875"/>
+            <a:ext cx="400050" cy="400050"/>
           </a:xfrm>
           <a:prstGeom xmlns:a="http://schemas.openxmlformats.org/drawingml/2006/main" prst="rect">
             <a:avLst/>
@@ -8614,9 +8620,9 @@
           <a:lstStyle xmlns:a="http://schemas.openxmlformats.org/drawingml/2006/main"/>
           <a:p xmlns:a="http://schemas.openxmlformats.org/drawingml/2006/main">
             <a:pPr algn="ctr">
-              <a:defRPr sz="1350" b="1">
-                <a:solidFill>
-                  <a:srgbClr val="FFFFFF"/>
+              <a:defRPr sz="1125" b="1">
+                <a:solidFill>
+                  <a:srgbClr val="2C6E73"/>
                 </a:solidFill>
                 <a:latin typeface="Arial"/>
                 <a:ea typeface="Arial"/>
@@ -8624,9 +8630,9 @@
               </a:defRPr>
             </a:pPr>
             <a:r>
-              <a:rPr sz="1350" b="1">
-                <a:solidFill>
-                  <a:srgbClr val="FFFFFF"/>
+              <a:rPr sz="1125" b="1">
+                <a:solidFill>
+                  <a:srgbClr val="2C6E73"/>
                 </a:solidFill>
                 <a:latin typeface="Arial"/>
                 <a:ea typeface="Arial"/>
@@ -8642,19 +8648,19 @@
           <p:cNvPr id="19" name="">
             <a:extLst xmlns:a="http://schemas.openxmlformats.org/drawingml/2006/main">
               <a:ext uri="{FF2B5EF4-FFF2-40B4-BE49-F238E27FC236}">
-                <a16:creationId xmlns:a16="http://schemas.microsoft.com/office/drawing/2014/main" id="{D4F8E06F-AC4C-4EE3-88ED-2D8FBE3379EB}"/>
-              </a:ext>
-            </a:extLst>
-          </p:cNvPr>
-          <p:cNvSpPr>
-            <a:spLocks xmlns:a="http://schemas.openxmlformats.org/drawingml/2006/main" noGrp="1"/>
-          </p:cNvSpPr>
-          <p:nvPr/>
-        </p:nvSpPr>
-        <p:spPr>
-          <a:xfrm xmlns:a="http://schemas.openxmlformats.org/drawingml/2006/main">
-            <a:off x="1714500" y="3667125"/>
-            <a:ext cx="9429750" cy="609600"/>
+                <a16:creationId xmlns:a16="http://schemas.microsoft.com/office/drawing/2014/main" id="{7CB703D1-8D5A-467A-A616-4DD0FC91DE3E}"/>
+              </a:ext>
+            </a:extLst>
+          </p:cNvPr>
+          <p:cNvSpPr>
+            <a:spLocks xmlns:a="http://schemas.openxmlformats.org/drawingml/2006/main" noGrp="1"/>
+          </p:cNvSpPr>
+          <p:nvPr/>
+        </p:nvSpPr>
+        <p:spPr>
+          <a:xfrm xmlns:a="http://schemas.openxmlformats.org/drawingml/2006/main">
+            <a:off x="1714500" y="3867150"/>
+            <a:ext cx="9525000" cy="809625"/>
           </a:xfrm>
           <a:prstGeom xmlns:a="http://schemas.openxmlformats.org/drawingml/2006/main" prst="rect">
             <a:avLst/>
@@ -8671,7 +8677,7 @@
           <a:lstStyle xmlns:a="http://schemas.openxmlformats.org/drawingml/2006/main"/>
           <a:p xmlns:a="http://schemas.openxmlformats.org/drawingml/2006/main">
             <a:pPr algn="l">
-              <a:defRPr sz="1500" b="0">
+              <a:defRPr sz="1725" b="0">
                 <a:solidFill>
                   <a:srgbClr val="17253A"/>
                 </a:solidFill>
@@ -8681,7 +8687,7 @@
               </a:defRPr>
             </a:pPr>
             <a:r>
-              <a:rPr sz="1500" b="0">
+              <a:rPr sz="1725" b="0">
                 <a:solidFill>
                   <a:srgbClr val="17253A"/>
                 </a:solidFill>
@@ -8689,7 +8695,7 @@
                 <a:ea typeface="Arial"/>
                 <a:cs typeface="Arial"/>
               </a:rPr>
-              <a:t>Complete the calculation: 11.</a:t>
+              <a:t>4 + 7 = 11</a:t>
             </a:r>
           </a:p>
         </p:txBody>
@@ -8699,28 +8705,30 @@
           <p:cNvPr id="20" name="">
             <a:extLst xmlns:a="http://schemas.openxmlformats.org/drawingml/2006/main">
               <a:ext uri="{FF2B5EF4-FFF2-40B4-BE49-F238E27FC236}">
-                <a16:creationId xmlns:a16="http://schemas.microsoft.com/office/drawing/2014/main" id="{9439D68D-12B9-4E85-9917-0DC8E878B348}"/>
-              </a:ext>
-            </a:extLst>
-          </p:cNvPr>
-          <p:cNvSpPr>
-            <a:spLocks xmlns:a="http://schemas.openxmlformats.org/drawingml/2006/main" noGrp="1"/>
-          </p:cNvSpPr>
-          <p:nvPr/>
-        </p:nvSpPr>
-        <p:spPr>
-          <a:xfrm xmlns:a="http://schemas.openxmlformats.org/drawingml/2006/main">
-            <a:off x="1000125" y="4476750"/>
-            <a:ext cx="476250" cy="476250"/>
-          </a:xfrm>
-          <a:prstGeom xmlns:a="http://schemas.openxmlformats.org/drawingml/2006/main" prst="ellipse">
+                <a16:creationId xmlns:a16="http://schemas.microsoft.com/office/drawing/2014/main" id="{118E2F5C-8543-4E71-BE9F-101D7FBE4B07}"/>
+              </a:ext>
+            </a:extLst>
+          </p:cNvPr>
+          <p:cNvSpPr>
+            <a:spLocks xmlns:a="http://schemas.openxmlformats.org/drawingml/2006/main" noGrp="1"/>
+          </p:cNvSpPr>
+          <p:nvPr/>
+        </p:nvSpPr>
+        <p:spPr>
+          <a:xfrm xmlns:a="http://schemas.openxmlformats.org/drawingml/2006/main">
+            <a:off x="1714500" y="4695825"/>
+            <a:ext cx="9334500" cy="9525"/>
+          </a:xfrm>
+          <a:prstGeom xmlns:a="http://schemas.openxmlformats.org/drawingml/2006/main" prst="rect">
             <a:avLst/>
           </a:prstGeom>
           <a:solidFill xmlns:a="http://schemas.openxmlformats.org/drawingml/2006/main">
-            <a:srgbClr val="2C6E73"/>
+            <a:srgbClr val="D9E0E6"/>
           </a:solidFill>
           <a:ln xmlns:a="http://schemas.openxmlformats.org/drawingml/2006/main" w="0">
-            <a:noFill/>
+            <a:solidFill>
+              <a:srgbClr val="D9E0E6"/>
+            </a:solidFill>
           </a:ln>
         </p:spPr>
       </p:sp>
@@ -8729,19 +8737,19 @@
           <p:cNvPr id="21" name="">
             <a:extLst xmlns:a="http://schemas.openxmlformats.org/drawingml/2006/main">
               <a:ext uri="{FF2B5EF4-FFF2-40B4-BE49-F238E27FC236}">
-                <a16:creationId xmlns:a16="http://schemas.microsoft.com/office/drawing/2014/main" id="{7889CB1F-7309-4033-B178-450EEEF5FDDC}"/>
-              </a:ext>
-            </a:extLst>
-          </p:cNvPr>
-          <p:cNvSpPr>
-            <a:spLocks xmlns:a="http://schemas.openxmlformats.org/drawingml/2006/main" noGrp="1"/>
-          </p:cNvSpPr>
-          <p:nvPr/>
-        </p:nvSpPr>
-        <p:spPr>
-          <a:xfrm xmlns:a="http://schemas.openxmlformats.org/drawingml/2006/main">
-            <a:off x="1000125" y="4505325"/>
-            <a:ext cx="476250" cy="419100"/>
+                <a16:creationId xmlns:a16="http://schemas.microsoft.com/office/drawing/2014/main" id="{86405399-856D-4C21-B366-EB5B6A616C09}"/>
+              </a:ext>
+            </a:extLst>
+          </p:cNvPr>
+          <p:cNvSpPr>
+            <a:spLocks xmlns:a="http://schemas.openxmlformats.org/drawingml/2006/main" noGrp="1"/>
+          </p:cNvSpPr>
+          <p:nvPr/>
+        </p:nvSpPr>
+        <p:spPr>
+          <a:xfrm xmlns:a="http://schemas.openxmlformats.org/drawingml/2006/main">
+            <a:off x="1162050" y="4829175"/>
+            <a:ext cx="400050" cy="400050"/>
           </a:xfrm>
           <a:prstGeom xmlns:a="http://schemas.openxmlformats.org/drawingml/2006/main" prst="rect">
             <a:avLst/>
@@ -8758,9 +8766,9 @@
           <a:lstStyle xmlns:a="http://schemas.openxmlformats.org/drawingml/2006/main"/>
           <a:p xmlns:a="http://schemas.openxmlformats.org/drawingml/2006/main">
             <a:pPr algn="ctr">
-              <a:defRPr sz="1350" b="1">
-                <a:solidFill>
-                  <a:srgbClr val="FFFFFF"/>
+              <a:defRPr sz="1125" b="1">
+                <a:solidFill>
+                  <a:srgbClr val="2F785D"/>
                 </a:solidFill>
                 <a:latin typeface="Arial"/>
                 <a:ea typeface="Arial"/>
@@ -8768,9 +8776,9 @@
               </a:defRPr>
             </a:pPr>
             <a:r>
-              <a:rPr sz="1350" b="1">
-                <a:solidFill>
-                  <a:srgbClr val="FFFFFF"/>
+              <a:rPr sz="1125" b="1">
+                <a:solidFill>
+                  <a:srgbClr val="2F785D"/>
                 </a:solidFill>
                 <a:latin typeface="Arial"/>
                 <a:ea typeface="Arial"/>
@@ -8786,19 +8794,19 @@
           <p:cNvPr id="22" name="">
             <a:extLst xmlns:a="http://schemas.openxmlformats.org/drawingml/2006/main">
               <a:ext uri="{FF2B5EF4-FFF2-40B4-BE49-F238E27FC236}">
-                <a16:creationId xmlns:a16="http://schemas.microsoft.com/office/drawing/2014/main" id="{F1EDEF26-5D7B-4684-92F1-CBDBB4640EC8}"/>
-              </a:ext>
-            </a:extLst>
-          </p:cNvPr>
-          <p:cNvSpPr>
-            <a:spLocks xmlns:a="http://schemas.openxmlformats.org/drawingml/2006/main" noGrp="1"/>
-          </p:cNvSpPr>
-          <p:nvPr/>
-        </p:nvSpPr>
-        <p:spPr>
-          <a:xfrm xmlns:a="http://schemas.openxmlformats.org/drawingml/2006/main">
-            <a:off x="1714500" y="4410075"/>
-            <a:ext cx="9429750" cy="609600"/>
+                <a16:creationId xmlns:a16="http://schemas.microsoft.com/office/drawing/2014/main" id="{361CD43C-8C99-4286-8C7D-DE3148CF76EF}"/>
+              </a:ext>
+            </a:extLst>
+          </p:cNvPr>
+          <p:cNvSpPr>
+            <a:spLocks xmlns:a="http://schemas.openxmlformats.org/drawingml/2006/main" noGrp="1"/>
+          </p:cNvSpPr>
+          <p:nvPr/>
+        </p:nvSpPr>
+        <p:spPr>
+          <a:xfrm xmlns:a="http://schemas.openxmlformats.org/drawingml/2006/main">
+            <a:off x="1714500" y="4743450"/>
+            <a:ext cx="9525000" cy="809625"/>
           </a:xfrm>
           <a:prstGeom xmlns:a="http://schemas.openxmlformats.org/drawingml/2006/main" prst="rect">
             <a:avLst/>
@@ -8815,7 +8823,7 @@
           <a:lstStyle xmlns:a="http://schemas.openxmlformats.org/drawingml/2006/main"/>
           <a:p xmlns:a="http://schemas.openxmlformats.org/drawingml/2006/main">
             <a:pPr algn="l">
-              <a:defRPr sz="1500" b="1">
+              <a:defRPr sz="1725" b="1">
                 <a:solidFill>
                   <a:srgbClr val="2F785D"/>
                 </a:solidFill>
@@ -8825,7 +8833,7 @@
               </a:defRPr>
             </a:pPr>
             <a:r>
-              <a:rPr sz="1500" b="1">
+              <a:rPr sz="1725" b="1">
                 <a:solidFill>
                   <a:srgbClr val="2F785D"/>
                 </a:solidFill>
@@ -8833,7 +8841,7 @@
                 <a:ea typeface="Arial"/>
                 <a:cs typeface="Arial"/>
               </a:rPr>
-              <a:t>Check the result: Check the value of every zero and compare from the greatest place.</a:t>
+              <a:t>The difference is 11</a:t>
             </a:r>
           </a:p>
         </p:txBody>
@@ -8841,7 +8849,7 @@
     </p:spTree>
     <p:extLst>
       <p:ext uri="{BB962C8B-B14F-4D97-AF65-F5344CB8AC3E}">
-        <p14:creationId xmlns:p14="http://schemas.microsoft.com/office/powerpoint/2010/main" val="1110972349"/>
+        <p14:creationId xmlns:p14="http://schemas.microsoft.com/office/powerpoint/2010/main" val="627640614"/>
       </p:ext>
     </p:extLst>
   </p:cSld>
@@ -9134,7 +9142,7 @@
           <p:cNvPr id="15" name="">
             <a:extLst xmlns:a="http://schemas.openxmlformats.org/drawingml/2006/main">
               <a:ext uri="{FF2B5EF4-FFF2-40B4-BE49-F238E27FC236}">
-                <a16:creationId xmlns:a16="http://schemas.microsoft.com/office/drawing/2014/main" id="{5CE72CF6-FC38-4FDE-BF3E-679556BB683A}"/>
+                <a16:creationId xmlns:a16="http://schemas.microsoft.com/office/drawing/2014/main" id="{16C61323-FCD0-49FD-B293-CBBA745A0FA5}"/>
               </a:ext>
             </a:extLst>
           </p:cNvPr>
@@ -9166,7 +9174,7 @@
           <p:cNvPr id="2" name="">
             <a:extLst xmlns:a="http://schemas.openxmlformats.org/drawingml/2006/main">
               <a:ext uri="{FF2B5EF4-FFF2-40B4-BE49-F238E27FC236}">
-                <a16:creationId xmlns:a16="http://schemas.microsoft.com/office/drawing/2014/main" id="{98CDBB98-1B0B-4AB4-83AD-870764020112}"/>
+                <a16:creationId xmlns:a16="http://schemas.microsoft.com/office/drawing/2014/main" id="{F81D9788-CAFA-40EE-B9D3-71F41BE09856}"/>
               </a:ext>
             </a:extLst>
           </p:cNvPr>
@@ -9223,7 +9231,7 @@
           <p:cNvPr id="3" name="">
             <a:extLst xmlns:a="http://schemas.openxmlformats.org/drawingml/2006/main">
               <a:ext uri="{FF2B5EF4-FFF2-40B4-BE49-F238E27FC236}">
-                <a16:creationId xmlns:a16="http://schemas.microsoft.com/office/drawing/2014/main" id="{FB58C03A-63CA-416D-ABD2-05727D26B9E6}"/>
+                <a16:creationId xmlns:a16="http://schemas.microsoft.com/office/drawing/2014/main" id="{96AF47EC-C201-4199-9A51-AD6A2B42A973}"/>
               </a:ext>
             </a:extLst>
           </p:cNvPr>
@@ -9255,7 +9263,7 @@
           <p:cNvPr id="4" name="">
             <a:extLst xmlns:a="http://schemas.openxmlformats.org/drawingml/2006/main">
               <a:ext uri="{FF2B5EF4-FFF2-40B4-BE49-F238E27FC236}">
-                <a16:creationId xmlns:a16="http://schemas.microsoft.com/office/drawing/2014/main" id="{0EA71F5C-68C9-4707-8207-9A9C83ED3EDE}"/>
+                <a16:creationId xmlns:a16="http://schemas.microsoft.com/office/drawing/2014/main" id="{FA4D8BE9-E61F-4DE5-95F5-A293493D7445}"/>
               </a:ext>
             </a:extLst>
           </p:cNvPr>
@@ -9312,7 +9320,7 @@
           <p:cNvPr id="5" name="">
             <a:extLst xmlns:a="http://schemas.openxmlformats.org/drawingml/2006/main">
               <a:ext uri="{FF2B5EF4-FFF2-40B4-BE49-F238E27FC236}">
-                <a16:creationId xmlns:a16="http://schemas.microsoft.com/office/drawing/2014/main" id="{65F94816-D412-40BE-9509-E2852E4B173E}"/>
+                <a16:creationId xmlns:a16="http://schemas.microsoft.com/office/drawing/2014/main" id="{902F7ABE-89C9-4B35-9A01-94D13DC372AF}"/>
               </a:ext>
             </a:extLst>
           </p:cNvPr>
@@ -9369,7 +9377,7 @@
           <p:cNvPr id="6" name="">
             <a:extLst xmlns:a="http://schemas.openxmlformats.org/drawingml/2006/main">
               <a:ext uri="{FF2B5EF4-FFF2-40B4-BE49-F238E27FC236}">
-                <a16:creationId xmlns:a16="http://schemas.microsoft.com/office/drawing/2014/main" id="{27427864-2DF4-4E36-A929-88656C49E466}"/>
+                <a16:creationId xmlns:a16="http://schemas.microsoft.com/office/drawing/2014/main" id="{EF50B723-3DA8-4F15-B642-2F35271ED300}"/>
               </a:ext>
             </a:extLst>
           </p:cNvPr>
@@ -9426,7 +9434,7 @@
           <p:cNvPr id="7" name="">
             <a:extLst xmlns:a="http://schemas.openxmlformats.org/drawingml/2006/main">
               <a:ext uri="{FF2B5EF4-FFF2-40B4-BE49-F238E27FC236}">
-                <a16:creationId xmlns:a16="http://schemas.microsoft.com/office/drawing/2014/main" id="{12D98510-FEDC-4F19-A7FF-5E3B91A71C51}"/>
+                <a16:creationId xmlns:a16="http://schemas.microsoft.com/office/drawing/2014/main" id="{C101F2D3-015B-4EDA-8C6A-0A6FE435FE02}"/>
               </a:ext>
             </a:extLst>
           </p:cNvPr>
@@ -9458,7 +9466,7 @@
           <p:cNvPr id="8" name="">
             <a:extLst xmlns:a="http://schemas.openxmlformats.org/drawingml/2006/main">
               <a:ext uri="{FF2B5EF4-FFF2-40B4-BE49-F238E27FC236}">
-                <a16:creationId xmlns:a16="http://schemas.microsoft.com/office/drawing/2014/main" id="{22F7CDB5-6C6F-4F3C-99DA-D1FC902B9143}"/>
+                <a16:creationId xmlns:a16="http://schemas.microsoft.com/office/drawing/2014/main" id="{97F9CEB1-AC1C-4FD7-A2BD-0457200F1C14}"/>
               </a:ext>
             </a:extLst>
           </p:cNvPr>
@@ -9515,7 +9523,7 @@
           <p:cNvPr id="9" name="">
             <a:extLst xmlns:a="http://schemas.openxmlformats.org/drawingml/2006/main">
               <a:ext uri="{FF2B5EF4-FFF2-40B4-BE49-F238E27FC236}">
-                <a16:creationId xmlns:a16="http://schemas.microsoft.com/office/drawing/2014/main" id="{1E80042C-D772-45D3-A612-E33AB124901F}"/>
+                <a16:creationId xmlns:a16="http://schemas.microsoft.com/office/drawing/2014/main" id="{D33BAA61-6BED-4453-AD96-AB453EA08C15}"/>
               </a:ext>
             </a:extLst>
           </p:cNvPr>
@@ -9572,7 +9580,7 @@
           <p:cNvPr id="10" name="">
             <a:extLst xmlns:a="http://schemas.openxmlformats.org/drawingml/2006/main">
               <a:ext uri="{FF2B5EF4-FFF2-40B4-BE49-F238E27FC236}">
-                <a16:creationId xmlns:a16="http://schemas.microsoft.com/office/drawing/2014/main" id="{3EEE6963-3188-493E-8BA0-B3BEE82DAB48}"/>
+                <a16:creationId xmlns:a16="http://schemas.microsoft.com/office/drawing/2014/main" id="{7EBCB656-877D-41FB-9461-9E7D7F81F6AD}"/>
               </a:ext>
             </a:extLst>
           </p:cNvPr>
@@ -9629,7 +9637,7 @@
           <p:cNvPr id="11" name="">
             <a:extLst xmlns:a="http://schemas.openxmlformats.org/drawingml/2006/main">
               <a:ext uri="{FF2B5EF4-FFF2-40B4-BE49-F238E27FC236}">
-                <a16:creationId xmlns:a16="http://schemas.microsoft.com/office/drawing/2014/main" id="{432AC408-457E-45CF-8E9D-B27CF6706545}"/>
+                <a16:creationId xmlns:a16="http://schemas.microsoft.com/office/drawing/2014/main" id="{95784E8F-4876-4638-8CF8-C6EE55DB9AE8}"/>
               </a:ext>
             </a:extLst>
           </p:cNvPr>
@@ -9686,7 +9694,7 @@
           <p:cNvPr id="12" name="">
             <a:extLst xmlns:a="http://schemas.openxmlformats.org/drawingml/2006/main">
               <a:ext uri="{FF2B5EF4-FFF2-40B4-BE49-F238E27FC236}">
-                <a16:creationId xmlns:a16="http://schemas.microsoft.com/office/drawing/2014/main" id="{62782F26-0E55-46F1-B271-436ED269AC68}"/>
+                <a16:creationId xmlns:a16="http://schemas.microsoft.com/office/drawing/2014/main" id="{6080DE15-B8B9-4C21-8941-C5A2344339DE}"/>
               </a:ext>
             </a:extLst>
           </p:cNvPr>
@@ -9718,7 +9726,7 @@
           <p:cNvPr id="13" name="">
             <a:extLst xmlns:a="http://schemas.openxmlformats.org/drawingml/2006/main">
               <a:ext uri="{FF2B5EF4-FFF2-40B4-BE49-F238E27FC236}">
-                <a16:creationId xmlns:a16="http://schemas.microsoft.com/office/drawing/2014/main" id="{7EDB13BF-761A-46A0-87D8-135DD4B5F0A2}"/>
+                <a16:creationId xmlns:a16="http://schemas.microsoft.com/office/drawing/2014/main" id="{BAF18513-8141-40CB-AB39-41D308AD262A}"/>
               </a:ext>
             </a:extLst>
           </p:cNvPr>
@@ -9775,7 +9783,7 @@
           <p:cNvPr id="14" name="">
             <a:extLst xmlns:a="http://schemas.openxmlformats.org/drawingml/2006/main">
               <a:ext uri="{FF2B5EF4-FFF2-40B4-BE49-F238E27FC236}">
-                <a16:creationId xmlns:a16="http://schemas.microsoft.com/office/drawing/2014/main" id="{2C3B9EC9-73CE-4DDC-8A37-57EBCA71B50A}"/>
+                <a16:creationId xmlns:a16="http://schemas.microsoft.com/office/drawing/2014/main" id="{131A9995-3A12-4F7C-BC0A-B74F90411302}"/>
               </a:ext>
             </a:extLst>
           </p:cNvPr>
@@ -9830,7 +9838,7 @@
     </p:spTree>
     <p:extLst>
       <p:ext uri="{BB962C8B-B14F-4D97-AF65-F5344CB8AC3E}">
-        <p14:creationId xmlns:p14="http://schemas.microsoft.com/office/powerpoint/2010/main" val="1816591640"/>
+        <p14:creationId xmlns:p14="http://schemas.microsoft.com/office/powerpoint/2010/main" val="1295468116"/>
       </p:ext>
     </p:extLst>
   </p:cSld>
@@ -10031,7 +10039,7 @@
           <p:cNvPr id="16" name="">
             <a:extLst xmlns:a="http://schemas.openxmlformats.org/drawingml/2006/main">
               <a:ext uri="{FF2B5EF4-FFF2-40B4-BE49-F238E27FC236}">
-                <a16:creationId xmlns:a16="http://schemas.microsoft.com/office/drawing/2014/main" id="{F8F033C1-F3F5-4077-B259-A480D404FEE9}"/>
+                <a16:creationId xmlns:a16="http://schemas.microsoft.com/office/drawing/2014/main" id="{662046AD-8297-4F60-9AF0-93F9082CD513}"/>
               </a:ext>
             </a:extLst>
           </p:cNvPr>
@@ -10063,7 +10071,7 @@
           <p:cNvPr id="2" name="">
             <a:extLst xmlns:a="http://schemas.openxmlformats.org/drawingml/2006/main">
               <a:ext uri="{FF2B5EF4-FFF2-40B4-BE49-F238E27FC236}">
-                <a16:creationId xmlns:a16="http://schemas.microsoft.com/office/drawing/2014/main" id="{FF86F954-221C-44E4-A2EC-3F5D6D85894D}"/>
+                <a16:creationId xmlns:a16="http://schemas.microsoft.com/office/drawing/2014/main" id="{A7AD1D5B-FAB9-49C9-8709-28CA1395C80D}"/>
               </a:ext>
             </a:extLst>
           </p:cNvPr>
@@ -10120,7 +10128,7 @@
           <p:cNvPr id="3" name="">
             <a:extLst xmlns:a="http://schemas.openxmlformats.org/drawingml/2006/main">
               <a:ext uri="{FF2B5EF4-FFF2-40B4-BE49-F238E27FC236}">
-                <a16:creationId xmlns:a16="http://schemas.microsoft.com/office/drawing/2014/main" id="{0B087B5F-9842-4946-918F-2AE33CEB1ECF}"/>
+                <a16:creationId xmlns:a16="http://schemas.microsoft.com/office/drawing/2014/main" id="{38C259EC-F6F2-4A27-8F92-5AF5DCBAD008}"/>
               </a:ext>
             </a:extLst>
           </p:cNvPr>
@@ -10152,7 +10160,7 @@
           <p:cNvPr id="4" name="">
             <a:extLst xmlns:a="http://schemas.openxmlformats.org/drawingml/2006/main">
               <a:ext uri="{FF2B5EF4-FFF2-40B4-BE49-F238E27FC236}">
-                <a16:creationId xmlns:a16="http://schemas.microsoft.com/office/drawing/2014/main" id="{0F63187C-C6F3-47DA-9C83-D177D023C664}"/>
+                <a16:creationId xmlns:a16="http://schemas.microsoft.com/office/drawing/2014/main" id="{35CF0B2E-2FDB-45C7-B112-BE43A27534C6}"/>
               </a:ext>
             </a:extLst>
           </p:cNvPr>
@@ -10209,7 +10217,7 @@
           <p:cNvPr id="5" name="">
             <a:extLst xmlns:a="http://schemas.openxmlformats.org/drawingml/2006/main">
               <a:ext uri="{FF2B5EF4-FFF2-40B4-BE49-F238E27FC236}">
-                <a16:creationId xmlns:a16="http://schemas.microsoft.com/office/drawing/2014/main" id="{231A1009-04A6-495A-9C3E-11B71AA47948}"/>
+                <a16:creationId xmlns:a16="http://schemas.microsoft.com/office/drawing/2014/main" id="{6F944991-C05F-4C20-BE73-4E92D15694E9}"/>
               </a:ext>
             </a:extLst>
           </p:cNvPr>
@@ -10266,7 +10274,7 @@
           <p:cNvPr id="6" name="">
             <a:extLst xmlns:a="http://schemas.openxmlformats.org/drawingml/2006/main">
               <a:ext uri="{FF2B5EF4-FFF2-40B4-BE49-F238E27FC236}">
-                <a16:creationId xmlns:a16="http://schemas.microsoft.com/office/drawing/2014/main" id="{244C9F0A-236A-42F8-9073-5AA492620D62}"/>
+                <a16:creationId xmlns:a16="http://schemas.microsoft.com/office/drawing/2014/main" id="{37505C5A-5763-44B6-BEB3-8EDF81EA7470}"/>
               </a:ext>
             </a:extLst>
           </p:cNvPr>
@@ -10323,7 +10331,7 @@
           <p:cNvPr id="7" name="">
             <a:extLst xmlns:a="http://schemas.openxmlformats.org/drawingml/2006/main">
               <a:ext uri="{FF2B5EF4-FFF2-40B4-BE49-F238E27FC236}">
-                <a16:creationId xmlns:a16="http://schemas.microsoft.com/office/drawing/2014/main" id="{4374DA3E-84BD-45A0-A912-062F4C1F157D}"/>
+                <a16:creationId xmlns:a16="http://schemas.microsoft.com/office/drawing/2014/main" id="{44532726-6FE1-47BF-B9D1-E46C29A690CA}"/>
               </a:ext>
             </a:extLst>
           </p:cNvPr>
@@ -10355,7 +10363,7 @@
           <p:cNvPr id="8" name="">
             <a:extLst xmlns:a="http://schemas.openxmlformats.org/drawingml/2006/main">
               <a:ext uri="{FF2B5EF4-FFF2-40B4-BE49-F238E27FC236}">
-                <a16:creationId xmlns:a16="http://schemas.microsoft.com/office/drawing/2014/main" id="{46FE501A-1A2C-4A87-8151-64B5F03EA9EF}"/>
+                <a16:creationId xmlns:a16="http://schemas.microsoft.com/office/drawing/2014/main" id="{3A7D8209-B52D-4824-B7DC-2DA6D887E442}"/>
               </a:ext>
             </a:extLst>
           </p:cNvPr>
@@ -10412,7 +10420,7 @@
           <p:cNvPr id="9" name="">
             <a:extLst xmlns:a="http://schemas.openxmlformats.org/drawingml/2006/main">
               <a:ext uri="{FF2B5EF4-FFF2-40B4-BE49-F238E27FC236}">
-                <a16:creationId xmlns:a16="http://schemas.microsoft.com/office/drawing/2014/main" id="{A2EDDEF6-5572-4EF6-AE4F-FFCFEE83FB00}"/>
+                <a16:creationId xmlns:a16="http://schemas.microsoft.com/office/drawing/2014/main" id="{CDA5EE12-F0CE-4FA5-9EF0-4E4A301F3A1B}"/>
               </a:ext>
             </a:extLst>
           </p:cNvPr>
@@ -10469,7 +10477,7 @@
           <p:cNvPr id="10" name="">
             <a:extLst xmlns:a="http://schemas.openxmlformats.org/drawingml/2006/main">
               <a:ext uri="{FF2B5EF4-FFF2-40B4-BE49-F238E27FC236}">
-                <a16:creationId xmlns:a16="http://schemas.microsoft.com/office/drawing/2014/main" id="{29999933-08E9-40AD-A2CE-2F57E7A7DA19}"/>
+                <a16:creationId xmlns:a16="http://schemas.microsoft.com/office/drawing/2014/main" id="{1F8D0591-35D3-4DDC-A3DD-FC106E4A9A1D}"/>
               </a:ext>
             </a:extLst>
           </p:cNvPr>
@@ -10526,7 +10534,7 @@
           <p:cNvPr id="11" name="">
             <a:extLst xmlns:a="http://schemas.openxmlformats.org/drawingml/2006/main">
               <a:ext uri="{FF2B5EF4-FFF2-40B4-BE49-F238E27FC236}">
-                <a16:creationId xmlns:a16="http://schemas.microsoft.com/office/drawing/2014/main" id="{B1E27F9D-013F-4CA0-ADE8-C60E9974F02E}"/>
+                <a16:creationId xmlns:a16="http://schemas.microsoft.com/office/drawing/2014/main" id="{6F950DFB-D7AC-44F2-8350-298883462985}"/>
               </a:ext>
             </a:extLst>
           </p:cNvPr>
@@ -10583,7 +10591,7 @@
           <p:cNvPr id="12" name="">
             <a:extLst xmlns:a="http://schemas.openxmlformats.org/drawingml/2006/main">
               <a:ext uri="{FF2B5EF4-FFF2-40B4-BE49-F238E27FC236}">
-                <a16:creationId xmlns:a16="http://schemas.microsoft.com/office/drawing/2014/main" id="{0DA7A803-83F1-48C9-9DA8-5DA96CD52B4E}"/>
+                <a16:creationId xmlns:a16="http://schemas.microsoft.com/office/drawing/2014/main" id="{D3897665-B14D-4BDE-9BA2-298FD9456758}"/>
               </a:ext>
             </a:extLst>
           </p:cNvPr>
@@ -10640,7 +10648,7 @@
           <p:cNvPr id="13" name="">
             <a:extLst xmlns:a="http://schemas.openxmlformats.org/drawingml/2006/main">
               <a:ext uri="{FF2B5EF4-FFF2-40B4-BE49-F238E27FC236}">
-                <a16:creationId xmlns:a16="http://schemas.microsoft.com/office/drawing/2014/main" id="{E5D9DAAF-6057-4B46-B6F0-57D2C41DE955}"/>
+                <a16:creationId xmlns:a16="http://schemas.microsoft.com/office/drawing/2014/main" id="{04A0180B-7BD7-44EE-8578-3E506C4F95DA}"/>
               </a:ext>
             </a:extLst>
           </p:cNvPr>
@@ -10697,7 +10705,7 @@
           <p:cNvPr id="14" name="">
             <a:extLst xmlns:a="http://schemas.openxmlformats.org/drawingml/2006/main">
               <a:ext uri="{FF2B5EF4-FFF2-40B4-BE49-F238E27FC236}">
-                <a16:creationId xmlns:a16="http://schemas.microsoft.com/office/drawing/2014/main" id="{C8D0D345-FB70-45D5-A03D-390174E658BC}"/>
+                <a16:creationId xmlns:a16="http://schemas.microsoft.com/office/drawing/2014/main" id="{83231DC7-E180-46E7-AD67-556FBE98E263}"/>
               </a:ext>
             </a:extLst>
           </p:cNvPr>
@@ -10754,7 +10762,7 @@
           <p:cNvPr id="15" name="">
             <a:extLst xmlns:a="http://schemas.openxmlformats.org/drawingml/2006/main">
               <a:ext uri="{FF2B5EF4-FFF2-40B4-BE49-F238E27FC236}">
-                <a16:creationId xmlns:a16="http://schemas.microsoft.com/office/drawing/2014/main" id="{2A033F28-4041-481F-B8B7-68E0DDC1AAEF}"/>
+                <a16:creationId xmlns:a16="http://schemas.microsoft.com/office/drawing/2014/main" id="{19F484A8-DD62-4B9E-A17E-B00D2E145F2F}"/>
               </a:ext>
             </a:extLst>
           </p:cNvPr>
@@ -10809,7 +10817,7 @@
     </p:spTree>
     <p:extLst>
       <p:ext uri="{BB962C8B-B14F-4D97-AF65-F5344CB8AC3E}">
-        <p14:creationId xmlns:p14="http://schemas.microsoft.com/office/powerpoint/2010/main" val="2033117613"/>
+        <p14:creationId xmlns:p14="http://schemas.microsoft.com/office/powerpoint/2010/main" val="1936298037"/>
       </p:ext>
     </p:extLst>
   </p:cSld>
@@ -10964,7 +10972,7 @@
           <p:cNvPr id="16" name="">
             <a:extLst xmlns:a="http://schemas.openxmlformats.org/drawingml/2006/main">
               <a:ext uri="{FF2B5EF4-FFF2-40B4-BE49-F238E27FC236}">
-                <a16:creationId xmlns:a16="http://schemas.microsoft.com/office/drawing/2014/main" id="{FA9235D2-CF35-455C-ADB9-16439B883CEA}"/>
+                <a16:creationId xmlns:a16="http://schemas.microsoft.com/office/drawing/2014/main" id="{F226C8A9-F253-4CDB-B1D6-6B10B9DE8377}"/>
               </a:ext>
             </a:extLst>
           </p:cNvPr>
@@ -10996,7 +11004,7 @@
           <p:cNvPr id="2" name="">
             <a:extLst xmlns:a="http://schemas.openxmlformats.org/drawingml/2006/main">
               <a:ext uri="{FF2B5EF4-FFF2-40B4-BE49-F238E27FC236}">
-                <a16:creationId xmlns:a16="http://schemas.microsoft.com/office/drawing/2014/main" id="{604CF470-CB81-497C-BB50-861A5224B31F}"/>
+                <a16:creationId xmlns:a16="http://schemas.microsoft.com/office/drawing/2014/main" id="{FB34FCDD-FFBA-4D3D-B6B3-6AD82FC939B8}"/>
               </a:ext>
             </a:extLst>
           </p:cNvPr>
@@ -11053,7 +11061,7 @@
           <p:cNvPr id="3" name="">
             <a:extLst xmlns:a="http://schemas.openxmlformats.org/drawingml/2006/main">
               <a:ext uri="{FF2B5EF4-FFF2-40B4-BE49-F238E27FC236}">
-                <a16:creationId xmlns:a16="http://schemas.microsoft.com/office/drawing/2014/main" id="{4B333B7D-D837-471C-99BC-239FC20AADF1}"/>
+                <a16:creationId xmlns:a16="http://schemas.microsoft.com/office/drawing/2014/main" id="{6182E12F-2C0B-4A3B-BD42-092CAF618FC3}"/>
               </a:ext>
             </a:extLst>
           </p:cNvPr>
@@ -11085,7 +11093,7 @@
           <p:cNvPr id="4" name="">
             <a:extLst xmlns:a="http://schemas.openxmlformats.org/drawingml/2006/main">
               <a:ext uri="{FF2B5EF4-FFF2-40B4-BE49-F238E27FC236}">
-                <a16:creationId xmlns:a16="http://schemas.microsoft.com/office/drawing/2014/main" id="{E4FC6037-3E80-4CDC-B2D7-F0BBF00678FA}"/>
+                <a16:creationId xmlns:a16="http://schemas.microsoft.com/office/drawing/2014/main" id="{41C743AE-17A9-4EE5-B2EC-21E472F12268}"/>
               </a:ext>
             </a:extLst>
           </p:cNvPr>
@@ -11142,7 +11150,7 @@
           <p:cNvPr id="5" name="">
             <a:extLst xmlns:a="http://schemas.openxmlformats.org/drawingml/2006/main">
               <a:ext uri="{FF2B5EF4-FFF2-40B4-BE49-F238E27FC236}">
-                <a16:creationId xmlns:a16="http://schemas.microsoft.com/office/drawing/2014/main" id="{3D9FC816-D5F2-4B88-AAC1-AC8854DAA5C4}"/>
+                <a16:creationId xmlns:a16="http://schemas.microsoft.com/office/drawing/2014/main" id="{27D7A5A3-0466-404B-9C4E-584B16FA2B3D}"/>
               </a:ext>
             </a:extLst>
           </p:cNvPr>
@@ -11199,7 +11207,7 @@
           <p:cNvPr id="6" name="">
             <a:extLst xmlns:a="http://schemas.openxmlformats.org/drawingml/2006/main">
               <a:ext uri="{FF2B5EF4-FFF2-40B4-BE49-F238E27FC236}">
-                <a16:creationId xmlns:a16="http://schemas.microsoft.com/office/drawing/2014/main" id="{FF59C692-51DE-4285-9D56-917E49CF342F}"/>
+                <a16:creationId xmlns:a16="http://schemas.microsoft.com/office/drawing/2014/main" id="{9DE1130B-EB55-4A29-B1CE-28D50EEBD430}"/>
               </a:ext>
             </a:extLst>
           </p:cNvPr>
@@ -11256,7 +11264,7 @@
           <p:cNvPr id="7" name="">
             <a:extLst xmlns:a="http://schemas.openxmlformats.org/drawingml/2006/main">
               <a:ext uri="{FF2B5EF4-FFF2-40B4-BE49-F238E27FC236}">
-                <a16:creationId xmlns:a16="http://schemas.microsoft.com/office/drawing/2014/main" id="{EA2C98F9-8AD8-4326-9934-C20B8F695D22}"/>
+                <a16:creationId xmlns:a16="http://schemas.microsoft.com/office/drawing/2014/main" id="{20ED405E-9C18-4423-B059-C01B7BF44557}"/>
               </a:ext>
             </a:extLst>
           </p:cNvPr>
@@ -11288,7 +11296,7 @@
           <p:cNvPr id="8" name="">
             <a:extLst xmlns:a="http://schemas.openxmlformats.org/drawingml/2006/main">
               <a:ext uri="{FF2B5EF4-FFF2-40B4-BE49-F238E27FC236}">
-                <a16:creationId xmlns:a16="http://schemas.microsoft.com/office/drawing/2014/main" id="{7E0DDA0C-993E-4C0E-8F38-125DE11AF0B8}"/>
+                <a16:creationId xmlns:a16="http://schemas.microsoft.com/office/drawing/2014/main" id="{5B8937C4-08D3-4326-86F3-A753182FDBA6}"/>
               </a:ext>
             </a:extLst>
           </p:cNvPr>
@@ -11345,7 +11353,7 @@
           <p:cNvPr id="9" name="">
             <a:extLst xmlns:a="http://schemas.openxmlformats.org/drawingml/2006/main">
               <a:ext uri="{FF2B5EF4-FFF2-40B4-BE49-F238E27FC236}">
-                <a16:creationId xmlns:a16="http://schemas.microsoft.com/office/drawing/2014/main" id="{FC9820A5-EE1A-43F2-9F1A-CFA2FD6FA16F}"/>
+                <a16:creationId xmlns:a16="http://schemas.microsoft.com/office/drawing/2014/main" id="{CCF2091D-40F4-471B-AA5A-3BBAEFF16D95}"/>
               </a:ext>
             </a:extLst>
           </p:cNvPr>
@@ -11406,7 +11414,7 @@
           <p:nvPr/>
         </p:nvPicPr>
         <p:blipFill>
-          <a:blip xmlns:r="http://schemas.openxmlformats.org/officeDocument/2006/relationships" xmlns:a="http://schemas.openxmlformats.org/drawingml/2006/main" r:embed="R8ab9ea4cb5674260"/>
+          <a:blip xmlns:r="http://schemas.openxmlformats.org/officeDocument/2006/relationships" xmlns:a="http://schemas.openxmlformats.org/drawingml/2006/main" r:embed="R277621eacd384ca0"/>
           <a:stretch xmlns:a="http://schemas.openxmlformats.org/drawingml/2006/main"/>
         </p:blipFill>
         <p:spPr>
@@ -11424,7 +11432,7 @@
           <p:cNvPr id="11" name="">
             <a:extLst xmlns:a="http://schemas.openxmlformats.org/drawingml/2006/main">
               <a:ext uri="{FF2B5EF4-FFF2-40B4-BE49-F238E27FC236}">
-                <a16:creationId xmlns:a16="http://schemas.microsoft.com/office/drawing/2014/main" id="{E54F9EDA-ED0F-4C80-9ACF-35FDE759B395}"/>
+                <a16:creationId xmlns:a16="http://schemas.microsoft.com/office/drawing/2014/main" id="{5825BA11-FD9B-4AE9-9FFD-B59027A43C12}"/>
               </a:ext>
             </a:extLst>
           </p:cNvPr>
@@ -11481,7 +11489,7 @@
           <p:cNvPr id="12" name="">
             <a:extLst xmlns:a="http://schemas.openxmlformats.org/drawingml/2006/main">
               <a:ext uri="{FF2B5EF4-FFF2-40B4-BE49-F238E27FC236}">
-                <a16:creationId xmlns:a16="http://schemas.microsoft.com/office/drawing/2014/main" id="{B6E2684D-7EC1-40E2-8CC8-11B878F969F4}"/>
+                <a16:creationId xmlns:a16="http://schemas.microsoft.com/office/drawing/2014/main" id="{322ED5F9-021A-45BF-9C18-8CAF3ED97D31}"/>
               </a:ext>
             </a:extLst>
           </p:cNvPr>
@@ -11538,7 +11546,7 @@
           <p:cNvPr id="13" name="">
             <a:extLst xmlns:a="http://schemas.openxmlformats.org/drawingml/2006/main">
               <a:ext uri="{FF2B5EF4-FFF2-40B4-BE49-F238E27FC236}">
-                <a16:creationId xmlns:a16="http://schemas.microsoft.com/office/drawing/2014/main" id="{681EC7A7-F3B1-4052-8B3A-3EC8A9AB7BD9}"/>
+                <a16:creationId xmlns:a16="http://schemas.microsoft.com/office/drawing/2014/main" id="{7A466C22-54A8-4679-AF3F-AAF82B0B0A21}"/>
               </a:ext>
             </a:extLst>
           </p:cNvPr>
@@ -11570,7 +11578,7 @@
           <p:cNvPr id="14" name="">
             <a:extLst xmlns:a="http://schemas.openxmlformats.org/drawingml/2006/main">
               <a:ext uri="{FF2B5EF4-FFF2-40B4-BE49-F238E27FC236}">
-                <a16:creationId xmlns:a16="http://schemas.microsoft.com/office/drawing/2014/main" id="{4F29A9C6-5E3F-4540-B544-E66869E60D46}"/>
+                <a16:creationId xmlns:a16="http://schemas.microsoft.com/office/drawing/2014/main" id="{F12FD1EE-C0F5-45BE-A63F-2966DDE608F2}"/>
               </a:ext>
             </a:extLst>
           </p:cNvPr>
@@ -11627,7 +11635,7 @@
           <p:cNvPr id="15" name="">
             <a:extLst xmlns:a="http://schemas.openxmlformats.org/drawingml/2006/main">
               <a:ext uri="{FF2B5EF4-FFF2-40B4-BE49-F238E27FC236}">
-                <a16:creationId xmlns:a16="http://schemas.microsoft.com/office/drawing/2014/main" id="{1BB3FF52-84C1-4721-8A11-BBBC6D3F08F9}"/>
+                <a16:creationId xmlns:a16="http://schemas.microsoft.com/office/drawing/2014/main" id="{43096A35-F004-4F32-8E5F-CD03CF02921A}"/>
               </a:ext>
             </a:extLst>
           </p:cNvPr>
@@ -11682,7 +11690,7 @@
     </p:spTree>
     <p:extLst>
       <p:ext uri="{BB962C8B-B14F-4D97-AF65-F5344CB8AC3E}">
-        <p14:creationId xmlns:p14="http://schemas.microsoft.com/office/powerpoint/2010/main" val="155977016"/>
+        <p14:creationId xmlns:p14="http://schemas.microsoft.com/office/powerpoint/2010/main" val="370038096"/>
       </p:ext>
     </p:extLst>
   </p:cSld>
@@ -11837,7 +11845,7 @@
           <p:cNvPr id="23" name="">
             <a:extLst xmlns:a="http://schemas.openxmlformats.org/drawingml/2006/main">
               <a:ext uri="{FF2B5EF4-FFF2-40B4-BE49-F238E27FC236}">
-                <a16:creationId xmlns:a16="http://schemas.microsoft.com/office/drawing/2014/main" id="{951F677D-4996-4041-9169-E64F5C7FF81E}"/>
+                <a16:creationId xmlns:a16="http://schemas.microsoft.com/office/drawing/2014/main" id="{10C6A8BD-4BBE-4962-A5BC-65D59A1AEEC7}"/>
               </a:ext>
             </a:extLst>
           </p:cNvPr>
@@ -11869,7 +11877,7 @@
           <p:cNvPr id="2" name="">
             <a:extLst xmlns:a="http://schemas.openxmlformats.org/drawingml/2006/main">
               <a:ext uri="{FF2B5EF4-FFF2-40B4-BE49-F238E27FC236}">
-                <a16:creationId xmlns:a16="http://schemas.microsoft.com/office/drawing/2014/main" id="{47CA274F-3722-493A-B5BE-C8DB45F2AC2F}"/>
+                <a16:creationId xmlns:a16="http://schemas.microsoft.com/office/drawing/2014/main" id="{9A6E4B76-6912-45AA-BB72-58A4B05748A6}"/>
               </a:ext>
             </a:extLst>
           </p:cNvPr>
@@ -11926,7 +11934,7 @@
           <p:cNvPr id="3" name="">
             <a:extLst xmlns:a="http://schemas.openxmlformats.org/drawingml/2006/main">
               <a:ext uri="{FF2B5EF4-FFF2-40B4-BE49-F238E27FC236}">
-                <a16:creationId xmlns:a16="http://schemas.microsoft.com/office/drawing/2014/main" id="{9DCF545F-DB85-49B8-851E-F8B5B7495F09}"/>
+                <a16:creationId xmlns:a16="http://schemas.microsoft.com/office/drawing/2014/main" id="{BC90D80D-3AB4-40B3-977E-955C686DAB37}"/>
               </a:ext>
             </a:extLst>
           </p:cNvPr>
@@ -11958,7 +11966,7 @@
           <p:cNvPr id="4" name="">
             <a:extLst xmlns:a="http://schemas.openxmlformats.org/drawingml/2006/main">
               <a:ext uri="{FF2B5EF4-FFF2-40B4-BE49-F238E27FC236}">
-                <a16:creationId xmlns:a16="http://schemas.microsoft.com/office/drawing/2014/main" id="{CB560CF1-9070-4102-AA08-A2AEF07596C4}"/>
+                <a16:creationId xmlns:a16="http://schemas.microsoft.com/office/drawing/2014/main" id="{083EC75B-1E85-49EE-AB75-10FF8AF33848}"/>
               </a:ext>
             </a:extLst>
           </p:cNvPr>
@@ -12015,7 +12023,7 @@
           <p:cNvPr id="5" name="">
             <a:extLst xmlns:a="http://schemas.openxmlformats.org/drawingml/2006/main">
               <a:ext uri="{FF2B5EF4-FFF2-40B4-BE49-F238E27FC236}">
-                <a16:creationId xmlns:a16="http://schemas.microsoft.com/office/drawing/2014/main" id="{A0FC52A4-18BC-48CA-A34B-FD4F2D641461}"/>
+                <a16:creationId xmlns:a16="http://schemas.microsoft.com/office/drawing/2014/main" id="{7D62B539-B34E-415B-AAAA-7127F682577A}"/>
               </a:ext>
             </a:extLst>
           </p:cNvPr>
@@ -12072,7 +12080,7 @@
           <p:cNvPr id="6" name="">
             <a:extLst xmlns:a="http://schemas.openxmlformats.org/drawingml/2006/main">
               <a:ext uri="{FF2B5EF4-FFF2-40B4-BE49-F238E27FC236}">
-                <a16:creationId xmlns:a16="http://schemas.microsoft.com/office/drawing/2014/main" id="{84B24860-2A33-475B-8DC8-9CA618AFCCAB}"/>
+                <a16:creationId xmlns:a16="http://schemas.microsoft.com/office/drawing/2014/main" id="{DAD49AF3-CC48-44C8-9E41-CCB949C051A5}"/>
               </a:ext>
             </a:extLst>
           </p:cNvPr>
@@ -12129,7 +12137,7 @@
           <p:cNvPr id="7" name="">
             <a:extLst xmlns:a="http://schemas.openxmlformats.org/drawingml/2006/main">
               <a:ext uri="{FF2B5EF4-FFF2-40B4-BE49-F238E27FC236}">
-                <a16:creationId xmlns:a16="http://schemas.microsoft.com/office/drawing/2014/main" id="{CB0130AD-BE09-473D-9FDD-B11676B33B26}"/>
+                <a16:creationId xmlns:a16="http://schemas.microsoft.com/office/drawing/2014/main" id="{4E1AD5E6-CA62-4171-AE71-47CC34C725F4}"/>
               </a:ext>
             </a:extLst>
           </p:cNvPr>
@@ -12161,7 +12169,7 @@
           <p:cNvPr id="8" name="">
             <a:extLst xmlns:a="http://schemas.openxmlformats.org/drawingml/2006/main">
               <a:ext uri="{FF2B5EF4-FFF2-40B4-BE49-F238E27FC236}">
-                <a16:creationId xmlns:a16="http://schemas.microsoft.com/office/drawing/2014/main" id="{741A5ECE-0F54-474C-8883-A274667B9DFC}"/>
+                <a16:creationId xmlns:a16="http://schemas.microsoft.com/office/drawing/2014/main" id="{3020F131-AA5A-4F74-BD38-8765550D2843}"/>
               </a:ext>
             </a:extLst>
           </p:cNvPr>
@@ -12218,7 +12226,7 @@
           <p:cNvPr id="9" name="">
             <a:extLst xmlns:a="http://schemas.openxmlformats.org/drawingml/2006/main">
               <a:ext uri="{FF2B5EF4-FFF2-40B4-BE49-F238E27FC236}">
-                <a16:creationId xmlns:a16="http://schemas.microsoft.com/office/drawing/2014/main" id="{7757411B-CDDF-421B-86C9-B210946FAC40}"/>
+                <a16:creationId xmlns:a16="http://schemas.microsoft.com/office/drawing/2014/main" id="{413F5228-C057-461B-BC09-5F12493C835A}"/>
               </a:ext>
             </a:extLst>
           </p:cNvPr>
@@ -12275,7 +12283,7 @@
           <p:cNvPr id="10" name="">
             <a:extLst xmlns:a="http://schemas.openxmlformats.org/drawingml/2006/main">
               <a:ext uri="{FF2B5EF4-FFF2-40B4-BE49-F238E27FC236}">
-                <a16:creationId xmlns:a16="http://schemas.microsoft.com/office/drawing/2014/main" id="{2C80CD00-EE4F-4170-B0F7-96A3415645E8}"/>
+                <a16:creationId xmlns:a16="http://schemas.microsoft.com/office/drawing/2014/main" id="{781989D6-0029-48DC-81C2-418EE67AEA26}"/>
               </a:ext>
             </a:extLst>
           </p:cNvPr>
@@ -12309,7 +12317,7 @@
           <p:cNvPr id="11" name="">
             <a:extLst xmlns:a="http://schemas.openxmlformats.org/drawingml/2006/main">
               <a:ext uri="{FF2B5EF4-FFF2-40B4-BE49-F238E27FC236}">
-                <a16:creationId xmlns:a16="http://schemas.microsoft.com/office/drawing/2014/main" id="{A859D883-9A63-46F0-9354-17D58C1881BA}"/>
+                <a16:creationId xmlns:a16="http://schemas.microsoft.com/office/drawing/2014/main" id="{785B58FE-5E99-4752-8381-F168D5B310B2}"/>
               </a:ext>
             </a:extLst>
           </p:cNvPr>
@@ -12341,7 +12349,7 @@
           <p:cNvPr id="12" name="">
             <a:extLst xmlns:a="http://schemas.openxmlformats.org/drawingml/2006/main">
               <a:ext uri="{FF2B5EF4-FFF2-40B4-BE49-F238E27FC236}">
-                <a16:creationId xmlns:a16="http://schemas.microsoft.com/office/drawing/2014/main" id="{8CE842A7-73F9-4E28-BA42-63859C6E0589}"/>
+                <a16:creationId xmlns:a16="http://schemas.microsoft.com/office/drawing/2014/main" id="{1762177F-579B-4470-9211-048FA6E30130}"/>
               </a:ext>
             </a:extLst>
           </p:cNvPr>
@@ -12398,7 +12406,7 @@
           <p:cNvPr id="13" name="">
             <a:extLst xmlns:a="http://schemas.openxmlformats.org/drawingml/2006/main">
               <a:ext uri="{FF2B5EF4-FFF2-40B4-BE49-F238E27FC236}">
-                <a16:creationId xmlns:a16="http://schemas.microsoft.com/office/drawing/2014/main" id="{BF280BE8-E2CE-467F-AE4C-7C52E5178F10}"/>
+                <a16:creationId xmlns:a16="http://schemas.microsoft.com/office/drawing/2014/main" id="{A93DDC64-DEA9-4A2F-90B4-AAAB709388D2}"/>
               </a:ext>
             </a:extLst>
           </p:cNvPr>
@@ -12455,7 +12463,7 @@
           <p:cNvPr id="14" name="">
             <a:extLst xmlns:a="http://schemas.openxmlformats.org/drawingml/2006/main">
               <a:ext uri="{FF2B5EF4-FFF2-40B4-BE49-F238E27FC236}">
-                <a16:creationId xmlns:a16="http://schemas.microsoft.com/office/drawing/2014/main" id="{FC0474F4-1E40-4515-96EC-3B214982835B}"/>
+                <a16:creationId xmlns:a16="http://schemas.microsoft.com/office/drawing/2014/main" id="{CE6B6FE3-04BA-45E1-A5E3-1509D4772818}"/>
               </a:ext>
             </a:extLst>
           </p:cNvPr>
@@ -12489,7 +12497,7 @@
           <p:cNvPr id="15" name="">
             <a:extLst xmlns:a="http://schemas.openxmlformats.org/drawingml/2006/main">
               <a:ext uri="{FF2B5EF4-FFF2-40B4-BE49-F238E27FC236}">
-                <a16:creationId xmlns:a16="http://schemas.microsoft.com/office/drawing/2014/main" id="{AF119044-2373-413D-9EE2-E65F360F8852}"/>
+                <a16:creationId xmlns:a16="http://schemas.microsoft.com/office/drawing/2014/main" id="{ADCDD248-CBA4-4360-9CBA-41C8348C8FD0}"/>
               </a:ext>
             </a:extLst>
           </p:cNvPr>
@@ -12521,7 +12529,7 @@
           <p:cNvPr id="16" name="">
             <a:extLst xmlns:a="http://schemas.openxmlformats.org/drawingml/2006/main">
               <a:ext uri="{FF2B5EF4-FFF2-40B4-BE49-F238E27FC236}">
-                <a16:creationId xmlns:a16="http://schemas.microsoft.com/office/drawing/2014/main" id="{C3BDB551-33BE-464A-8B9D-05E1B255C21D}"/>
+                <a16:creationId xmlns:a16="http://schemas.microsoft.com/office/drawing/2014/main" id="{1BC0EC77-80AA-4262-BACD-53A9C0F67815}"/>
               </a:ext>
             </a:extLst>
           </p:cNvPr>
@@ -12578,7 +12586,7 @@
           <p:cNvPr id="17" name="">
             <a:extLst xmlns:a="http://schemas.openxmlformats.org/drawingml/2006/main">
               <a:ext uri="{FF2B5EF4-FFF2-40B4-BE49-F238E27FC236}">
-                <a16:creationId xmlns:a16="http://schemas.microsoft.com/office/drawing/2014/main" id="{AB113DCF-0539-49C1-A553-E2DC03E4085C}"/>
+                <a16:creationId xmlns:a16="http://schemas.microsoft.com/office/drawing/2014/main" id="{5FDBCFCF-FCF4-4406-A797-F8F4EE94EFBB}"/>
               </a:ext>
             </a:extLst>
           </p:cNvPr>
@@ -12635,7 +12643,7 @@
           <p:cNvPr id="18" name="">
             <a:extLst xmlns:a="http://schemas.openxmlformats.org/drawingml/2006/main">
               <a:ext uri="{FF2B5EF4-FFF2-40B4-BE49-F238E27FC236}">
-                <a16:creationId xmlns:a16="http://schemas.microsoft.com/office/drawing/2014/main" id="{8DD95B72-EF79-48C4-A515-391E597D6437}"/>
+                <a16:creationId xmlns:a16="http://schemas.microsoft.com/office/drawing/2014/main" id="{F8A3DD62-4193-4238-A3FD-E9E536BB7C0C}"/>
               </a:ext>
             </a:extLst>
           </p:cNvPr>
@@ -12669,7 +12677,7 @@
           <p:cNvPr id="19" name="">
             <a:extLst xmlns:a="http://schemas.openxmlformats.org/drawingml/2006/main">
               <a:ext uri="{FF2B5EF4-FFF2-40B4-BE49-F238E27FC236}">
-                <a16:creationId xmlns:a16="http://schemas.microsoft.com/office/drawing/2014/main" id="{2A6D5DD8-49BD-44E8-BD87-BEACDFD7662D}"/>
+                <a16:creationId xmlns:a16="http://schemas.microsoft.com/office/drawing/2014/main" id="{5B879FA6-3A16-4A73-AD52-C13EFDD75D48}"/>
               </a:ext>
             </a:extLst>
           </p:cNvPr>
@@ -12701,7 +12709,7 @@
           <p:cNvPr id="20" name="">
             <a:extLst xmlns:a="http://schemas.openxmlformats.org/drawingml/2006/main">
               <a:ext uri="{FF2B5EF4-FFF2-40B4-BE49-F238E27FC236}">
-                <a16:creationId xmlns:a16="http://schemas.microsoft.com/office/drawing/2014/main" id="{2E1B99A7-282F-479B-8BA5-CB606996E43F}"/>
+                <a16:creationId xmlns:a16="http://schemas.microsoft.com/office/drawing/2014/main" id="{EA6FE7CE-F3A9-4386-AD32-3BDD84FE565D}"/>
               </a:ext>
             </a:extLst>
           </p:cNvPr>
@@ -12758,7 +12766,7 @@
           <p:cNvPr id="21" name="">
             <a:extLst xmlns:a="http://schemas.openxmlformats.org/drawingml/2006/main">
               <a:ext uri="{FF2B5EF4-FFF2-40B4-BE49-F238E27FC236}">
-                <a16:creationId xmlns:a16="http://schemas.microsoft.com/office/drawing/2014/main" id="{B59F5978-0F1F-4A2B-BFDA-B122DF302BA7}"/>
+                <a16:creationId xmlns:a16="http://schemas.microsoft.com/office/drawing/2014/main" id="{9F4FF1D9-A348-43CA-95DA-6EC71CD633D7}"/>
               </a:ext>
             </a:extLst>
           </p:cNvPr>
@@ -12815,7 +12823,7 @@
           <p:cNvPr id="22" name="">
             <a:extLst xmlns:a="http://schemas.openxmlformats.org/drawingml/2006/main">
               <a:ext uri="{FF2B5EF4-FFF2-40B4-BE49-F238E27FC236}">
-                <a16:creationId xmlns:a16="http://schemas.microsoft.com/office/drawing/2014/main" id="{8D59D24D-762B-4560-BFE0-3EDE386B7D86}"/>
+                <a16:creationId xmlns:a16="http://schemas.microsoft.com/office/drawing/2014/main" id="{E30C8700-099A-4035-B20E-136A0A0BF0AF}"/>
               </a:ext>
             </a:extLst>
           </p:cNvPr>
@@ -12870,7 +12878,7 @@
     </p:spTree>
     <p:extLst>
       <p:ext uri="{BB962C8B-B14F-4D97-AF65-F5344CB8AC3E}">
-        <p14:creationId xmlns:p14="http://schemas.microsoft.com/office/powerpoint/2010/main" val="1328886398"/>
+        <p14:creationId xmlns:p14="http://schemas.microsoft.com/office/powerpoint/2010/main" val="1925357102"/>
       </p:ext>
     </p:extLst>
   </p:cSld>
@@ -13071,7 +13079,7 @@
           <p:cNvPr id="22" name="">
             <a:extLst xmlns:a="http://schemas.openxmlformats.org/drawingml/2006/main">
               <a:ext uri="{FF2B5EF4-FFF2-40B4-BE49-F238E27FC236}">
-                <a16:creationId xmlns:a16="http://schemas.microsoft.com/office/drawing/2014/main" id="{C55D4846-B332-4927-9AE4-D7FDF6CD41C3}"/>
+                <a16:creationId xmlns:a16="http://schemas.microsoft.com/office/drawing/2014/main" id="{726E1563-A909-482D-8C18-2D08D76ECB3C}"/>
               </a:ext>
             </a:extLst>
           </p:cNvPr>
@@ -13103,7 +13111,7 @@
           <p:cNvPr id="2" name="">
             <a:extLst xmlns:a="http://schemas.openxmlformats.org/drawingml/2006/main">
               <a:ext uri="{FF2B5EF4-FFF2-40B4-BE49-F238E27FC236}">
-                <a16:creationId xmlns:a16="http://schemas.microsoft.com/office/drawing/2014/main" id="{2D3D794B-9C57-4290-8D69-FDA90FC58EC5}"/>
+                <a16:creationId xmlns:a16="http://schemas.microsoft.com/office/drawing/2014/main" id="{39FFE610-B7FB-4E36-BBC9-4F6549A75F86}"/>
               </a:ext>
             </a:extLst>
           </p:cNvPr>
@@ -13160,7 +13168,7 @@
           <p:cNvPr id="3" name="">
             <a:extLst xmlns:a="http://schemas.openxmlformats.org/drawingml/2006/main">
               <a:ext uri="{FF2B5EF4-FFF2-40B4-BE49-F238E27FC236}">
-                <a16:creationId xmlns:a16="http://schemas.microsoft.com/office/drawing/2014/main" id="{B23F96DE-0C94-4EE9-ABFD-E662CFD1B0E6}"/>
+                <a16:creationId xmlns:a16="http://schemas.microsoft.com/office/drawing/2014/main" id="{14AF68CD-17E7-4BA2-AE68-011C000310AD}"/>
               </a:ext>
             </a:extLst>
           </p:cNvPr>
@@ -13192,7 +13200,7 @@
           <p:cNvPr id="4" name="">
             <a:extLst xmlns:a="http://schemas.openxmlformats.org/drawingml/2006/main">
               <a:ext uri="{FF2B5EF4-FFF2-40B4-BE49-F238E27FC236}">
-                <a16:creationId xmlns:a16="http://schemas.microsoft.com/office/drawing/2014/main" id="{DE76B031-7EAA-4692-B551-172D26FE6951}"/>
+                <a16:creationId xmlns:a16="http://schemas.microsoft.com/office/drawing/2014/main" id="{501DC5AD-6693-4EA2-A4B1-CFE4A3779E62}"/>
               </a:ext>
             </a:extLst>
           </p:cNvPr>
@@ -13249,7 +13257,7 @@
           <p:cNvPr id="5" name="">
             <a:extLst xmlns:a="http://schemas.openxmlformats.org/drawingml/2006/main">
               <a:ext uri="{FF2B5EF4-FFF2-40B4-BE49-F238E27FC236}">
-                <a16:creationId xmlns:a16="http://schemas.microsoft.com/office/drawing/2014/main" id="{8EAA58F0-8B3C-461E-A8A5-B3155CCD213A}"/>
+                <a16:creationId xmlns:a16="http://schemas.microsoft.com/office/drawing/2014/main" id="{12EFE9BE-0B5D-487B-A114-53746DA6E41B}"/>
               </a:ext>
             </a:extLst>
           </p:cNvPr>
@@ -13306,7 +13314,7 @@
           <p:cNvPr id="6" name="">
             <a:extLst xmlns:a="http://schemas.openxmlformats.org/drawingml/2006/main">
               <a:ext uri="{FF2B5EF4-FFF2-40B4-BE49-F238E27FC236}">
-                <a16:creationId xmlns:a16="http://schemas.microsoft.com/office/drawing/2014/main" id="{3BBAA5A9-E9EC-415F-8A1B-1171B2EFE605}"/>
+                <a16:creationId xmlns:a16="http://schemas.microsoft.com/office/drawing/2014/main" id="{DB17D1D5-28C8-4F70-8A6C-53DF49D40440}"/>
               </a:ext>
             </a:extLst>
           </p:cNvPr>
@@ -13363,7 +13371,7 @@
           <p:cNvPr id="7" name="">
             <a:extLst xmlns:a="http://schemas.openxmlformats.org/drawingml/2006/main">
               <a:ext uri="{FF2B5EF4-FFF2-40B4-BE49-F238E27FC236}">
-                <a16:creationId xmlns:a16="http://schemas.microsoft.com/office/drawing/2014/main" id="{CE30717B-7A24-42AD-925C-4FB459DF5D62}"/>
+                <a16:creationId xmlns:a16="http://schemas.microsoft.com/office/drawing/2014/main" id="{2958B65A-1426-4A22-9905-1EB28244DEA5}"/>
               </a:ext>
             </a:extLst>
           </p:cNvPr>
@@ -13395,7 +13403,7 @@
           <p:cNvPr id="8" name="">
             <a:extLst xmlns:a="http://schemas.openxmlformats.org/drawingml/2006/main">
               <a:ext uri="{FF2B5EF4-FFF2-40B4-BE49-F238E27FC236}">
-                <a16:creationId xmlns:a16="http://schemas.microsoft.com/office/drawing/2014/main" id="{3AB23EE3-6E7A-415C-983F-33051452E6B0}"/>
+                <a16:creationId xmlns:a16="http://schemas.microsoft.com/office/drawing/2014/main" id="{09D11A11-3FA1-4B3D-B477-784C89E0240A}"/>
               </a:ext>
             </a:extLst>
           </p:cNvPr>
@@ -13452,7 +13460,7 @@
           <p:cNvPr id="9" name="">
             <a:extLst xmlns:a="http://schemas.openxmlformats.org/drawingml/2006/main">
               <a:ext uri="{FF2B5EF4-FFF2-40B4-BE49-F238E27FC236}">
-                <a16:creationId xmlns:a16="http://schemas.microsoft.com/office/drawing/2014/main" id="{1E16878D-7B66-4ADA-B4C9-EB9CA609F26C}"/>
+                <a16:creationId xmlns:a16="http://schemas.microsoft.com/office/drawing/2014/main" id="{1BB1B09A-957D-483E-9944-A80721DD2CBF}"/>
               </a:ext>
             </a:extLst>
           </p:cNvPr>
@@ -13509,7 +13517,7 @@
           <p:cNvPr id="10" name="">
             <a:extLst xmlns:a="http://schemas.openxmlformats.org/drawingml/2006/main">
               <a:ext uri="{FF2B5EF4-FFF2-40B4-BE49-F238E27FC236}">
-                <a16:creationId xmlns:a16="http://schemas.microsoft.com/office/drawing/2014/main" id="{74AAF271-83AA-4286-B660-668C9E2190F2}"/>
+                <a16:creationId xmlns:a16="http://schemas.microsoft.com/office/drawing/2014/main" id="{D184E10A-41D9-4940-9FB9-AC128345F086}"/>
               </a:ext>
             </a:extLst>
           </p:cNvPr>
@@ -13543,7 +13551,7 @@
           <p:cNvPr id="11" name="">
             <a:extLst xmlns:a="http://schemas.openxmlformats.org/drawingml/2006/main">
               <a:ext uri="{FF2B5EF4-FFF2-40B4-BE49-F238E27FC236}">
-                <a16:creationId xmlns:a16="http://schemas.microsoft.com/office/drawing/2014/main" id="{D8A62647-3323-4CE3-8384-CA40A2712006}"/>
+                <a16:creationId xmlns:a16="http://schemas.microsoft.com/office/drawing/2014/main" id="{3F04DFE0-9CA9-4B4B-822A-86066A127FC4}"/>
               </a:ext>
             </a:extLst>
           </p:cNvPr>
@@ -13575,7 +13583,7 @@
           <p:cNvPr id="12" name="">
             <a:extLst xmlns:a="http://schemas.openxmlformats.org/drawingml/2006/main">
               <a:ext uri="{FF2B5EF4-FFF2-40B4-BE49-F238E27FC236}">
-                <a16:creationId xmlns:a16="http://schemas.microsoft.com/office/drawing/2014/main" id="{1824E8A1-EB6B-4B79-8932-226D0C2441E8}"/>
+                <a16:creationId xmlns:a16="http://schemas.microsoft.com/office/drawing/2014/main" id="{FF6E951A-548F-4046-96E4-781D917432E4}"/>
               </a:ext>
             </a:extLst>
           </p:cNvPr>
@@ -13632,7 +13640,7 @@
           <p:cNvPr id="13" name="">
             <a:extLst xmlns:a="http://schemas.openxmlformats.org/drawingml/2006/main">
               <a:ext uri="{FF2B5EF4-FFF2-40B4-BE49-F238E27FC236}">
-                <a16:creationId xmlns:a16="http://schemas.microsoft.com/office/drawing/2014/main" id="{EAC8B9DA-671E-43DD-9486-A90B208CE8C9}"/>
+                <a16:creationId xmlns:a16="http://schemas.microsoft.com/office/drawing/2014/main" id="{AC4A0ADE-E85B-47E3-8D96-F981E248676E}"/>
               </a:ext>
             </a:extLst>
           </p:cNvPr>
@@ -13689,7 +13697,7 @@
           <p:cNvPr id="14" name="">
             <a:extLst xmlns:a="http://schemas.openxmlformats.org/drawingml/2006/main">
               <a:ext uri="{FF2B5EF4-FFF2-40B4-BE49-F238E27FC236}">
-                <a16:creationId xmlns:a16="http://schemas.microsoft.com/office/drawing/2014/main" id="{B39D47F6-7FE5-4C94-952D-067F14203BF4}"/>
+                <a16:creationId xmlns:a16="http://schemas.microsoft.com/office/drawing/2014/main" id="{35697C23-F594-41CC-9471-64E553F2E260}"/>
               </a:ext>
             </a:extLst>
           </p:cNvPr>
@@ -13723,7 +13731,7 @@
           <p:cNvPr id="15" name="">
             <a:extLst xmlns:a="http://schemas.openxmlformats.org/drawingml/2006/main">
               <a:ext uri="{FF2B5EF4-FFF2-40B4-BE49-F238E27FC236}">
-                <a16:creationId xmlns:a16="http://schemas.microsoft.com/office/drawing/2014/main" id="{281D6E82-F156-46EA-8798-8DC811419C22}"/>
+                <a16:creationId xmlns:a16="http://schemas.microsoft.com/office/drawing/2014/main" id="{39CF6821-4DC2-4E07-9D82-8CF611C7F430}"/>
               </a:ext>
             </a:extLst>
           </p:cNvPr>
@@ -13755,7 +13763,7 @@
           <p:cNvPr id="16" name="">
             <a:extLst xmlns:a="http://schemas.openxmlformats.org/drawingml/2006/main">
               <a:ext uri="{FF2B5EF4-FFF2-40B4-BE49-F238E27FC236}">
-                <a16:creationId xmlns:a16="http://schemas.microsoft.com/office/drawing/2014/main" id="{D22D784F-A409-4F5B-8A06-D4B0B18F7D91}"/>
+                <a16:creationId xmlns:a16="http://schemas.microsoft.com/office/drawing/2014/main" id="{972A1C80-47C1-4B0A-BECF-C24F77B3CD38}"/>
               </a:ext>
             </a:extLst>
           </p:cNvPr>
@@ -13812,7 +13820,7 @@
           <p:cNvPr id="17" name="">
             <a:extLst xmlns:a="http://schemas.openxmlformats.org/drawingml/2006/main">
               <a:ext uri="{FF2B5EF4-FFF2-40B4-BE49-F238E27FC236}">
-                <a16:creationId xmlns:a16="http://schemas.microsoft.com/office/drawing/2014/main" id="{9B0AD4DF-7658-4555-AE36-FBECEEFC75A2}"/>
+                <a16:creationId xmlns:a16="http://schemas.microsoft.com/office/drawing/2014/main" id="{3D83E1DD-D3D4-4C9E-A3F9-F030429CE98A}"/>
               </a:ext>
             </a:extLst>
           </p:cNvPr>
@@ -13869,7 +13877,7 @@
           <p:cNvPr id="18" name="">
             <a:extLst xmlns:a="http://schemas.openxmlformats.org/drawingml/2006/main">
               <a:ext uri="{FF2B5EF4-FFF2-40B4-BE49-F238E27FC236}">
-                <a16:creationId xmlns:a16="http://schemas.microsoft.com/office/drawing/2014/main" id="{FE313BED-02E7-4D22-B319-729BBE799BE2}"/>
+                <a16:creationId xmlns:a16="http://schemas.microsoft.com/office/drawing/2014/main" id="{1892C869-B846-4E2B-B07A-516415A56AD9}"/>
               </a:ext>
             </a:extLst>
           </p:cNvPr>
@@ -13903,7 +13911,7 @@
           <p:cNvPr id="19" name="">
             <a:extLst xmlns:a="http://schemas.openxmlformats.org/drawingml/2006/main">
               <a:ext uri="{FF2B5EF4-FFF2-40B4-BE49-F238E27FC236}">
-                <a16:creationId xmlns:a16="http://schemas.microsoft.com/office/drawing/2014/main" id="{C9C7684B-82BC-4BB6-8EE0-6E0B9B2E954A}"/>
+                <a16:creationId xmlns:a16="http://schemas.microsoft.com/office/drawing/2014/main" id="{A079C0C2-5A19-4FC0-81F4-D7B7AFC9355E}"/>
               </a:ext>
             </a:extLst>
           </p:cNvPr>
@@ -13935,7 +13943,7 @@
           <p:cNvPr id="20" name="">
             <a:extLst xmlns:a="http://schemas.openxmlformats.org/drawingml/2006/main">
               <a:ext uri="{FF2B5EF4-FFF2-40B4-BE49-F238E27FC236}">
-                <a16:creationId xmlns:a16="http://schemas.microsoft.com/office/drawing/2014/main" id="{6C852FAA-57E8-4DEA-93AE-3DED8FE74AF8}"/>
+                <a16:creationId xmlns:a16="http://schemas.microsoft.com/office/drawing/2014/main" id="{8B05146A-67E4-4716-B495-390D646D34AA}"/>
               </a:ext>
             </a:extLst>
           </p:cNvPr>
@@ -13992,7 +14000,7 @@
           <p:cNvPr id="21" name="">
             <a:extLst xmlns:a="http://schemas.openxmlformats.org/drawingml/2006/main">
               <a:ext uri="{FF2B5EF4-FFF2-40B4-BE49-F238E27FC236}">
-                <a16:creationId xmlns:a16="http://schemas.microsoft.com/office/drawing/2014/main" id="{72F59373-795C-43C1-B503-1F433A531541}"/>
+                <a16:creationId xmlns:a16="http://schemas.microsoft.com/office/drawing/2014/main" id="{6F780A63-06FD-4642-AAFE-F001156376FC}"/>
               </a:ext>
             </a:extLst>
           </p:cNvPr>
@@ -14047,7 +14055,7 @@
     </p:spTree>
     <p:extLst>
       <p:ext uri="{BB962C8B-B14F-4D97-AF65-F5344CB8AC3E}">
-        <p14:creationId xmlns:p14="http://schemas.microsoft.com/office/powerpoint/2010/main" val="503477680"/>
+        <p14:creationId xmlns:p14="http://schemas.microsoft.com/office/powerpoint/2010/main" val="1604304501"/>
       </p:ext>
     </p:extLst>
   </p:cSld>

</xml_diff>